<commit_message>
Deck amendments from HK Vinay: KPI, partner order, email
1. Remove the tax-saved figure from slide 2. It was the fourth KPI, so
   the band re-grids from 4-up to 3-up on the deck's own column math.
   The figure is still published on twchartered.com, so site and deck
   now diverge.
2. Partner order is Shabari, HK Vinay, Akshay, Vagdev — the Managing
   Partner sits second by his own instruction.
3. HK Vinay's address becomes cahkv@twchartered.com on slide 16. The
   site still lists the old address. The shorter string also lets the
   contact block sit on the 3-up grid, aligned with the cards above it,
   instead of the ad-hoc widths the long address needed.

brief.md gains a change log recording both site/deck divergences.

Gates: validate clean, view issues 0.

Co-Authored-By: Claude Opus 5 <noreply@anthropic.com>
Claude-Session: https://claude.ai/code/session_019z6znKoXgkS3KRD4bBqrbf
</commit_message>
<xml_diff>
--- a/singapore-deck/taxwise-singapore.pptx
+++ b/singapore-deck/taxwise-singapore.pptx
@@ -5,25 +5,25 @@
     <p:sldMasterId xmlns:r="http://schemas.openxmlformats.org/officeDocument/2006/relationships" id="2147483648" r:id="rId1"/>
   </p:sldMasterIdLst>
   <p:notesMasterIdLst>
-    <p:notesMasterId r:id="R0494cccf25194aa9"/>
+    <p:notesMasterId r:id="R56a9006fb9e248d2"/>
   </p:notesMasterIdLst>
   <p:sldIdLst>
-    <p:sldId id="256" r:id="Re1f5868843e84531"/>
-    <p:sldId id="257" r:id="Rc94a8e18f3084367"/>
-    <p:sldId id="258" r:id="R39e38e0410a548cc"/>
-    <p:sldId id="259" r:id="R2a74e1db1faa4046"/>
-    <p:sldId id="260" r:id="R90ad741ba341433d"/>
-    <p:sldId id="261" r:id="R29fbb77d5c784bb4"/>
-    <p:sldId id="262" r:id="R5e679600d0b64b22"/>
-    <p:sldId id="263" r:id="R0fa31e3f527c4086"/>
-    <p:sldId id="264" r:id="Re1d0a42f7bd34106"/>
-    <p:sldId id="265" r:id="Rd0d53df402814f8f"/>
-    <p:sldId id="266" r:id="Ra3efbc7a95d24f2f"/>
-    <p:sldId id="267" r:id="Reb9530dce13947ff"/>
-    <p:sldId id="268" r:id="R54d06356fee94162"/>
-    <p:sldId id="269" r:id="R1a86fd3a992e42d6"/>
-    <p:sldId id="270" r:id="R67e47d610bab4c57"/>
-    <p:sldId id="271" r:id="R967d7af0c4374323"/>
+    <p:sldId id="256" r:id="Rd58cf227236a4ef1"/>
+    <p:sldId id="257" r:id="R0f5aed4fbbe54282"/>
+    <p:sldId id="258" r:id="Rfc01610f42814962"/>
+    <p:sldId id="259" r:id="Rab75c4c6431f481b"/>
+    <p:sldId id="260" r:id="R9b4a28c9957d4432"/>
+    <p:sldId id="261" r:id="R4b80013543894482"/>
+    <p:sldId id="262" r:id="Rc1b5bb1a8f1346b1"/>
+    <p:sldId id="263" r:id="R22310309403b456c"/>
+    <p:sldId id="264" r:id="R0e78697b83f04fa8"/>
+    <p:sldId id="265" r:id="R76f0114ce81b4a6d"/>
+    <p:sldId id="266" r:id="R57174691eea94996"/>
+    <p:sldId id="267" r:id="R682390e7d9fe4bfb"/>
+    <p:sldId id="268" r:id="R9af8a8f90ac743b8"/>
+    <p:sldId id="269" r:id="R779e40e24a8649ba"/>
+    <p:sldId id="270" r:id="R5b07fb05d7cb4e81"/>
+    <p:sldId id="271" r:id="Re1c6dc30e08c4a3a"/>
   </p:sldIdLst>
   <p:sldSz cx="12192000" cy="6858000"/>
   <p:notesSz cx="6858000" cy="9144000"/>
@@ -486,7 +486,7 @@
           <a:p xmlns:a="http://schemas.openxmlformats.org/drawingml/2006/main">
             <a:r>
               <a:rPr lang="en-US"/>
-              <a:t>Open by establishing that this is an established practice, not a new venture. Ten years, 500 clients, 30 people in-house. Chennai is the second office. Do not rush the four figures — let them land before moving on.</a:t>
+              <a:t>Open by establishing that this is an established practice, not a new venture. Ten years, 500 clients, 30 people in-house. Chennai is the second office. Do not rush the three figures — let them land before moving on.</a:t>
             </a:r>
           </a:p>
         </p:txBody>
@@ -1771,7 +1771,7 @@
           <p:nvPr/>
         </p:nvPicPr>
         <p:blipFill>
-          <a:blip xmlns:r="http://schemas.openxmlformats.org/officeDocument/2006/relationships" xmlns:a="http://schemas.openxmlformats.org/drawingml/2006/main" r:embed="R26c3c8e54a614d82"/>
+          <a:blip xmlns:r="http://schemas.openxmlformats.org/officeDocument/2006/relationships" xmlns:a="http://schemas.openxmlformats.org/drawingml/2006/main" r:embed="R2365bdba2062428b"/>
           <a:stretch xmlns:a="http://schemas.openxmlformats.org/drawingml/2006/main">
             <a:fillRect/>
           </a:stretch>
@@ -2102,7 +2102,7 @@
       <p:grpSpPr/>
       <p:sp>
         <p:nvSpPr>
-          <p:cNvPr id="100172" name="!!scene-orb-gold"/>
+          <p:cNvPr id="100170" name="!!scene-orb-gold"/>
           <p:cNvSpPr/>
           <p:nvPr/>
         </p:nvSpPr>
@@ -2139,7 +2139,7 @@
       </p:sp>
       <p:sp>
         <p:nvSpPr>
-          <p:cNvPr id="100173" name="!!scene-orb-steel"/>
+          <p:cNvPr id="100171" name="!!scene-orb-steel"/>
           <p:cNvSpPr/>
           <p:nvPr/>
         </p:nvSpPr>
@@ -2176,7 +2176,7 @@
       </p:sp>
       <p:sp>
         <p:nvSpPr>
-          <p:cNvPr id="100174" name="!!scene-wash"/>
+          <p:cNvPr id="100172" name="!!scene-wash"/>
           <p:cNvSpPr/>
           <p:nvPr/>
         </p:nvSpPr>
@@ -2207,7 +2207,7 @@
       </p:sp>
       <p:sp>
         <p:nvSpPr>
-          <p:cNvPr id="100175" name="!!scene-rule-navy"/>
+          <p:cNvPr id="100173" name="!!scene-rule-navy"/>
           <p:cNvSpPr/>
           <p:nvPr/>
         </p:nvSpPr>
@@ -2234,7 +2234,7 @@
       </p:sp>
       <p:sp>
         <p:nvSpPr>
-          <p:cNvPr id="100176" name="!!scene-rule-gold"/>
+          <p:cNvPr id="100174" name="!!scene-rule-gold"/>
           <p:cNvSpPr/>
           <p:nvPr/>
         </p:nvSpPr>
@@ -2261,7 +2261,7 @@
       </p:sp>
       <p:sp>
         <p:nvSpPr>
-          <p:cNvPr id="100177" name="!!scene-dot"/>
+          <p:cNvPr id="100175" name="!!scene-dot"/>
           <p:cNvSpPr/>
           <p:nvPr/>
         </p:nvSpPr>
@@ -2288,7 +2288,7 @@
       </p:sp>
       <p:sp>
         <p:nvSpPr>
-          <p:cNvPr id="100178" name="!!#s10-topbar"/>
+          <p:cNvPr id="100176" name="!!#s10-topbar"/>
           <p:cNvSpPr txBox="1"/>
           <p:nvPr/>
         </p:nvSpPr>
@@ -2325,7 +2325,7 @@
       </p:sp>
       <p:sp>
         <p:nvSpPr>
-          <p:cNvPr id="100179" name="!!#s10-num"/>
+          <p:cNvPr id="100177" name="!!#s10-num"/>
           <p:cNvSpPr txBox="1"/>
           <p:nvPr/>
         </p:nvSpPr>
@@ -2362,7 +2362,7 @@
       </p:sp>
       <p:sp>
         <p:nvSpPr>
-          <p:cNvPr id="100180" name="!!#s10-title"/>
+          <p:cNvPr id="100178" name="!!#s10-title"/>
           <p:cNvSpPr txBox="1"/>
           <p:nvPr/>
         </p:nvSpPr>
@@ -2399,7 +2399,7 @@
       </p:sp>
       <p:sp>
         <p:nvSpPr>
-          <p:cNvPr id="100181" name="!!#s10-strap"/>
+          <p:cNvPr id="100179" name="!!#s10-strap"/>
           <p:cNvSpPr txBox="1"/>
           <p:nvPr/>
         </p:nvSpPr>
@@ -2440,7 +2440,7 @@
       </p:sp>
       <p:sp>
         <p:nvSpPr>
-          <p:cNvPr id="100182" name="!!actor-corridor"/>
+          <p:cNvPr id="100180" name="!!actor-corridor"/>
           <p:cNvSpPr/>
           <p:nvPr/>
         </p:nvSpPr>
@@ -2513,7 +2513,7 @@
                                           </p:stCondLst>
                                         </p:cTn>
                                         <p:tgtEl>
-                                          <p:spTgt spid="100180"/>
+                                          <p:spTgt spid="100178"/>
                                         </p:tgtEl>
                                         <p:attrNameLst>
                                           <p:attrName>style.visibility</p:attrName>
@@ -2527,7 +2527,7 @@
                                       <p:cBhvr>
                                         <p:cTn id="5" dur="400"/>
                                         <p:tgtEl>
-                                          <p:spTgt spid="100180"/>
+                                          <p:spTgt spid="100178"/>
                                         </p:tgtEl>
                                       </p:cBhvr>
                                     </p:animEffect>
@@ -2566,7 +2566,7 @@
                                           </p:stCondLst>
                                         </p:cTn>
                                         <p:tgtEl>
-                                          <p:spTgt spid="100179"/>
+                                          <p:spTgt spid="100177"/>
                                         </p:tgtEl>
                                         <p:attrNameLst>
                                           <p:attrName>style.visibility</p:attrName>
@@ -2580,7 +2580,7 @@
                                       <p:cBhvr>
                                         <p:cTn id="11" dur="500"/>
                                         <p:tgtEl>
-                                          <p:spTgt spid="100179"/>
+                                          <p:spTgt spid="100177"/>
                                         </p:tgtEl>
                                       </p:cBhvr>
                                     </p:animEffect>
@@ -2615,8 +2615,8 @@
       </p:par>
     </p:tnLst>
     <p:bldLst>
-      <p:bldP spid="100180" grpId="0"/>
-      <p:bldP spid="100179" grpId="1"/>
+      <p:bldP spid="100178" grpId="0"/>
+      <p:bldP spid="100177" grpId="1"/>
     </p:bldLst>
   </p:timing>
 </p:sld>
@@ -2641,7 +2641,7 @@
       <p:grpSpPr/>
       <p:sp>
         <p:nvSpPr>
-          <p:cNvPr id="100183" name="!!scene-orb-gold"/>
+          <p:cNvPr id="100181" name="!!scene-orb-gold"/>
           <p:cNvSpPr/>
           <p:nvPr/>
         </p:nvSpPr>
@@ -2678,7 +2678,7 @@
       </p:sp>
       <p:sp>
         <p:nvSpPr>
-          <p:cNvPr id="100184" name="!!scene-orb-steel"/>
+          <p:cNvPr id="100182" name="!!scene-orb-steel"/>
           <p:cNvSpPr/>
           <p:nvPr/>
         </p:nvSpPr>
@@ -2715,7 +2715,7 @@
       </p:sp>
       <p:sp>
         <p:nvSpPr>
-          <p:cNvPr id="100185" name="!!scene-wash"/>
+          <p:cNvPr id="100183" name="!!scene-wash"/>
           <p:cNvSpPr/>
           <p:nvPr/>
         </p:nvSpPr>
@@ -2746,7 +2746,7 @@
       </p:sp>
       <p:sp>
         <p:nvSpPr>
-          <p:cNvPr id="100186" name="!!scene-rule-navy"/>
+          <p:cNvPr id="100184" name="!!scene-rule-navy"/>
           <p:cNvSpPr/>
           <p:nvPr/>
         </p:nvSpPr>
@@ -2773,7 +2773,7 @@
       </p:sp>
       <p:sp>
         <p:nvSpPr>
-          <p:cNvPr id="100187" name="!!scene-rule-gold"/>
+          <p:cNvPr id="100185" name="!!scene-rule-gold"/>
           <p:cNvSpPr/>
           <p:nvPr/>
         </p:nvSpPr>
@@ -2800,7 +2800,7 @@
       </p:sp>
       <p:sp>
         <p:nvSpPr>
-          <p:cNvPr id="100188" name="!!scene-dot"/>
+          <p:cNvPr id="100186" name="!!scene-dot"/>
           <p:cNvSpPr/>
           <p:nvPr/>
         </p:nvSpPr>
@@ -2827,7 +2827,7 @@
       </p:sp>
       <p:sp>
         <p:nvSpPr>
-          <p:cNvPr id="100189" name="!!scene-footrule"/>
+          <p:cNvPr id="100187" name="!!scene-footrule"/>
           <p:cNvSpPr/>
           <p:nvPr/>
         </p:nvSpPr>
@@ -2854,7 +2854,7 @@
       </p:sp>
       <p:sp>
         <p:nvSpPr>
-          <p:cNvPr id="100190" name="!!#s11-eye-sec"/>
+          <p:cNvPr id="100188" name="!!#s11-eye-sec"/>
           <p:cNvSpPr txBox="1"/>
           <p:nvPr/>
         </p:nvSpPr>
@@ -2891,7 +2891,7 @@
       </p:sp>
       <p:sp>
         <p:nvSpPr>
-          <p:cNvPr id="100191" name="!!#s11-title"/>
+          <p:cNvPr id="100189" name="!!#s11-title"/>
           <p:cNvSpPr txBox="1"/>
           <p:nvPr/>
         </p:nvSpPr>
@@ -2928,7 +2928,7 @@
       </p:sp>
       <p:sp>
         <p:nvSpPr>
-          <p:cNvPr id="100192" name="!!actor-corridor"/>
+          <p:cNvPr id="100190" name="!!actor-corridor"/>
           <p:cNvSpPr/>
           <p:nvPr/>
         </p:nvSpPr>
@@ -2955,7 +2955,7 @@
       </p:sp>
       <p:sp>
         <p:nvSpPr>
-          <p:cNvPr id="100193" name="!!#s11-pole2"/>
+          <p:cNvPr id="100191" name="!!#s11-pole2"/>
           <p:cNvSpPr/>
           <p:nvPr/>
         </p:nvSpPr>
@@ -2986,7 +2986,7 @@
       </p:sp>
       <p:sp>
         <p:nvSpPr>
-          <p:cNvPr id="100194" name="!!#s11-eye-pole0"/>
+          <p:cNvPr id="100192" name="!!#s11-eye-pole0"/>
           <p:cNvSpPr txBox="1"/>
           <p:nvPr/>
         </p:nvSpPr>
@@ -3023,7 +3023,7 @@
       </p:sp>
       <p:sp>
         <p:nvSpPr>
-          <p:cNvPr id="100195" name="!!#s11-phead0"/>
+          <p:cNvPr id="100193" name="!!#s11-phead0"/>
           <p:cNvSpPr txBox="1"/>
           <p:nvPr/>
         </p:nvSpPr>
@@ -3060,7 +3060,7 @@
       </p:sp>
       <p:sp>
         <p:nvSpPr>
-          <p:cNvPr id="100196" name="!!#s11-pbody0"/>
+          <p:cNvPr id="100194" name="!!#s11-pbody0"/>
           <p:cNvSpPr txBox="1"/>
           <p:nvPr/>
         </p:nvSpPr>
@@ -3101,7 +3101,7 @@
       </p:sp>
       <p:sp>
         <p:nvSpPr>
-          <p:cNvPr id="100197" name="!!#s11-eye-pole1"/>
+          <p:cNvPr id="100195" name="!!#s11-eye-pole1"/>
           <p:cNvSpPr txBox="1"/>
           <p:nvPr/>
         </p:nvSpPr>
@@ -3138,7 +3138,7 @@
       </p:sp>
       <p:sp>
         <p:nvSpPr>
-          <p:cNvPr id="100198" name="!!#s11-phead1"/>
+          <p:cNvPr id="100196" name="!!#s11-phead1"/>
           <p:cNvSpPr txBox="1"/>
           <p:nvPr/>
         </p:nvSpPr>
@@ -3175,7 +3175,7 @@
       </p:sp>
       <p:sp>
         <p:nvSpPr>
-          <p:cNvPr id="100199" name="!!#s11-pbody1"/>
+          <p:cNvPr id="100197" name="!!#s11-pbody1"/>
           <p:cNvSpPr txBox="1"/>
           <p:nvPr/>
         </p:nvSpPr>
@@ -3216,7 +3216,7 @@
       </p:sp>
       <p:sp>
         <p:nvSpPr>
-          <p:cNvPr id="100200" name="!!#s11-tag0"/>
+          <p:cNvPr id="100198" name="!!#s11-tag0"/>
           <p:cNvSpPr/>
           <p:nvPr/>
         </p:nvSpPr>
@@ -3255,7 +3255,7 @@
       </p:sp>
       <p:sp>
         <p:nvSpPr>
-          <p:cNvPr id="100201" name="!!#s11-tag1"/>
+          <p:cNvPr id="100199" name="!!#s11-tag1"/>
           <p:cNvSpPr/>
           <p:nvPr/>
         </p:nvSpPr>
@@ -3294,7 +3294,7 @@
       </p:sp>
       <p:sp>
         <p:nvSpPr>
-          <p:cNvPr id="100202" name="!!#s11-tag2"/>
+          <p:cNvPr id="100200" name="!!#s11-tag2"/>
           <p:cNvSpPr/>
           <p:nvPr/>
         </p:nvSpPr>
@@ -3333,7 +3333,7 @@
       </p:sp>
       <p:sp>
         <p:nvSpPr>
-          <p:cNvPr id="100203" name="!!#s11-eye-cross"/>
+          <p:cNvPr id="100201" name="!!#s11-eye-cross"/>
           <p:cNvSpPr txBox="1"/>
           <p:nvPr/>
         </p:nvSpPr>
@@ -3370,7 +3370,7 @@
       </p:sp>
       <p:sp>
         <p:nvSpPr>
-          <p:cNvPr id="100204" name="!!#s11-crossb"/>
+          <p:cNvPr id="100202" name="!!#s11-crossb"/>
           <p:cNvSpPr txBox="1"/>
           <p:nvPr/>
         </p:nvSpPr>
@@ -3411,7 +3411,7 @@
       </p:sp>
       <p:sp>
         <p:nvSpPr>
-          <p:cNvPr id="100205" name="!!#s11-foot"/>
+          <p:cNvPr id="100203" name="!!#s11-foot"/>
           <p:cNvSpPr txBox="1"/>
           <p:nvPr/>
         </p:nvSpPr>
@@ -3448,7 +3448,7 @@
       </p:sp>
       <p:sp>
         <p:nvSpPr>
-          <p:cNvPr id="100206" name="!!#s11-pageno"/>
+          <p:cNvPr id="100204" name="!!#s11-pageno"/>
           <p:cNvSpPr txBox="1"/>
           <p:nvPr/>
         </p:nvSpPr>
@@ -3531,7 +3531,7 @@
                                           </p:stCondLst>
                                         </p:cTn>
                                         <p:tgtEl>
-                                          <p:spTgt spid="100191"/>
+                                          <p:spTgt spid="100189"/>
                                         </p:tgtEl>
                                         <p:attrNameLst>
                                           <p:attrName>style.visibility</p:attrName>
@@ -3545,7 +3545,7 @@
                                       <p:cBhvr>
                                         <p:cTn id="5" dur="400"/>
                                         <p:tgtEl>
-                                          <p:spTgt spid="100191"/>
+                                          <p:spTgt spid="100189"/>
                                         </p:tgtEl>
                                       </p:cBhvr>
                                     </p:animEffect>
@@ -3584,7 +3584,7 @@
                                           </p:stCondLst>
                                         </p:cTn>
                                         <p:tgtEl>
-                                          <p:spTgt spid="100195"/>
+                                          <p:spTgt spid="100193"/>
                                         </p:tgtEl>
                                         <p:attrNameLst>
                                           <p:attrName>style.visibility</p:attrName>
@@ -3598,7 +3598,7 @@
                                       <p:cBhvr>
                                         <p:cTn id="11" dur="450"/>
                                         <p:tgtEl>
-                                          <p:spTgt spid="100195"/>
+                                          <p:spTgt spid="100193"/>
                                         </p:tgtEl>
                                       </p:cBhvr>
                                     </p:animEffect>
@@ -3633,8 +3633,8 @@
       </p:par>
     </p:tnLst>
     <p:bldLst>
-      <p:bldP spid="100191" grpId="0"/>
-      <p:bldP spid="100195" grpId="1"/>
+      <p:bldP spid="100189" grpId="0"/>
+      <p:bldP spid="100193" grpId="1"/>
     </p:bldLst>
   </p:timing>
 </p:sld>
@@ -3659,7 +3659,7 @@
       <p:grpSpPr/>
       <p:sp>
         <p:nvSpPr>
-          <p:cNvPr id="100207" name="!!scene-orb-gold"/>
+          <p:cNvPr id="100205" name="!!scene-orb-gold"/>
           <p:cNvSpPr/>
           <p:nvPr/>
         </p:nvSpPr>
@@ -3696,7 +3696,7 @@
       </p:sp>
       <p:sp>
         <p:nvSpPr>
-          <p:cNvPr id="100208" name="!!scene-orb-steel"/>
+          <p:cNvPr id="100206" name="!!scene-orb-steel"/>
           <p:cNvSpPr/>
           <p:nvPr/>
         </p:nvSpPr>
@@ -3733,7 +3733,7 @@
       </p:sp>
       <p:sp>
         <p:nvSpPr>
-          <p:cNvPr id="100209" name="!!scene-wash"/>
+          <p:cNvPr id="100207" name="!!scene-wash"/>
           <p:cNvSpPr/>
           <p:nvPr/>
         </p:nvSpPr>
@@ -3764,7 +3764,7 @@
       </p:sp>
       <p:sp>
         <p:nvSpPr>
-          <p:cNvPr id="100210" name="!!scene-rule-navy"/>
+          <p:cNvPr id="100208" name="!!scene-rule-navy"/>
           <p:cNvSpPr/>
           <p:nvPr/>
         </p:nvSpPr>
@@ -3791,7 +3791,7 @@
       </p:sp>
       <p:sp>
         <p:nvSpPr>
-          <p:cNvPr id="100211" name="!!scene-rule-gold"/>
+          <p:cNvPr id="100209" name="!!scene-rule-gold"/>
           <p:cNvSpPr/>
           <p:nvPr/>
         </p:nvSpPr>
@@ -3818,7 +3818,7 @@
       </p:sp>
       <p:sp>
         <p:nvSpPr>
-          <p:cNvPr id="100212" name="!!scene-dot"/>
+          <p:cNvPr id="100210" name="!!scene-dot"/>
           <p:cNvSpPr/>
           <p:nvPr/>
         </p:nvSpPr>
@@ -3845,7 +3845,7 @@
       </p:sp>
       <p:sp>
         <p:nvSpPr>
-          <p:cNvPr id="100213" name="!!scene-footrule"/>
+          <p:cNvPr id="100211" name="!!scene-footrule"/>
           <p:cNvSpPr/>
           <p:nvPr/>
         </p:nvSpPr>
@@ -3872,7 +3872,7 @@
       </p:sp>
       <p:sp>
         <p:nvSpPr>
-          <p:cNvPr id="100214" name="!!#s12-eye-sec"/>
+          <p:cNvPr id="100212" name="!!#s12-eye-sec"/>
           <p:cNvSpPr txBox="1"/>
           <p:nvPr/>
         </p:nvSpPr>
@@ -3909,7 +3909,7 @@
       </p:sp>
       <p:sp>
         <p:nvSpPr>
-          <p:cNvPr id="100215" name="!!#s12-title"/>
+          <p:cNvPr id="100213" name="!!#s12-title"/>
           <p:cNvSpPr txBox="1"/>
           <p:nvPr/>
         </p:nvSpPr>
@@ -3946,7 +3946,7 @@
       </p:sp>
       <p:sp>
         <p:nvSpPr>
-          <p:cNvPr id="100216" name="!!actor-corridor"/>
+          <p:cNvPr id="100214" name="!!actor-corridor"/>
           <p:cNvSpPr/>
           <p:nvPr/>
         </p:nvSpPr>
@@ -3973,7 +3973,7 @@
       </p:sp>
       <p:sp>
         <p:nvSpPr>
-          <p:cNvPr id="100217" name="!!#s12-eye-c0"/>
+          <p:cNvPr id="100215" name="!!#s12-eye-c0"/>
           <p:cNvSpPr txBox="1"/>
           <p:nvPr/>
         </p:nvSpPr>
@@ -4010,7 +4010,7 @@
       </p:sp>
       <p:sp>
         <p:nvSpPr>
-          <p:cNvPr id="100218" name="!!#s12-chead0"/>
+          <p:cNvPr id="100216" name="!!#s12-chead0"/>
           <p:cNvSpPr txBox="1"/>
           <p:nvPr/>
         </p:nvSpPr>
@@ -4051,7 +4051,7 @@
       </p:sp>
       <p:sp>
         <p:nvSpPr>
-          <p:cNvPr id="100219" name="!!#s12-cbody0"/>
+          <p:cNvPr id="100217" name="!!#s12-cbody0"/>
           <p:cNvSpPr txBox="1"/>
           <p:nvPr/>
         </p:nvSpPr>
@@ -4092,7 +4092,7 @@
       </p:sp>
       <p:sp>
         <p:nvSpPr>
-          <p:cNvPr id="100220" name="!!#s12-card1"/>
+          <p:cNvPr id="100218" name="!!#s12-card1"/>
           <p:cNvSpPr/>
           <p:nvPr/>
         </p:nvSpPr>
@@ -4123,7 +4123,7 @@
       </p:sp>
       <p:sp>
         <p:nvSpPr>
-          <p:cNvPr id="100221" name="!!#s12-eye-c1"/>
+          <p:cNvPr id="100219" name="!!#s12-eye-c1"/>
           <p:cNvSpPr txBox="1"/>
           <p:nvPr/>
         </p:nvSpPr>
@@ -4160,7 +4160,7 @@
       </p:sp>
       <p:sp>
         <p:nvSpPr>
-          <p:cNvPr id="100222" name="!!#s12-chead1"/>
+          <p:cNvPr id="100220" name="!!#s12-chead1"/>
           <p:cNvSpPr txBox="1"/>
           <p:nvPr/>
         </p:nvSpPr>
@@ -4201,7 +4201,7 @@
       </p:sp>
       <p:sp>
         <p:nvSpPr>
-          <p:cNvPr id="100223" name="!!#s12-cbody1"/>
+          <p:cNvPr id="100221" name="!!#s12-cbody1"/>
           <p:cNvSpPr txBox="1"/>
           <p:nvPr/>
         </p:nvSpPr>
@@ -4242,7 +4242,7 @@
       </p:sp>
       <p:sp>
         <p:nvSpPr>
-          <p:cNvPr id="100224" name="!!#s12-card2"/>
+          <p:cNvPr id="100222" name="!!#s12-card2"/>
           <p:cNvSpPr/>
           <p:nvPr/>
         </p:nvSpPr>
@@ -4273,7 +4273,7 @@
       </p:sp>
       <p:sp>
         <p:nvSpPr>
-          <p:cNvPr id="100225" name="!!#s12-eye-c2"/>
+          <p:cNvPr id="100223" name="!!#s12-eye-c2"/>
           <p:cNvSpPr txBox="1"/>
           <p:nvPr/>
         </p:nvSpPr>
@@ -4310,7 +4310,7 @@
       </p:sp>
       <p:sp>
         <p:nvSpPr>
-          <p:cNvPr id="100226" name="!!#s12-chead2"/>
+          <p:cNvPr id="100224" name="!!#s12-chead2"/>
           <p:cNvSpPr txBox="1"/>
           <p:nvPr/>
         </p:nvSpPr>
@@ -4351,7 +4351,7 @@
       </p:sp>
       <p:sp>
         <p:nvSpPr>
-          <p:cNvPr id="100227" name="!!#s12-cbody2"/>
+          <p:cNvPr id="100225" name="!!#s12-cbody2"/>
           <p:cNvSpPr txBox="1"/>
           <p:nvPr/>
         </p:nvSpPr>
@@ -4392,7 +4392,7 @@
       </p:sp>
       <p:sp>
         <p:nvSpPr>
-          <p:cNvPr id="100228" name="!!#s12-foot"/>
+          <p:cNvPr id="100226" name="!!#s12-foot"/>
           <p:cNvSpPr txBox="1"/>
           <p:nvPr/>
         </p:nvSpPr>
@@ -4429,7 +4429,7 @@
       </p:sp>
       <p:sp>
         <p:nvSpPr>
-          <p:cNvPr id="100229" name="!!#s12-pageno"/>
+          <p:cNvPr id="100227" name="!!#s12-pageno"/>
           <p:cNvSpPr txBox="1"/>
           <p:nvPr/>
         </p:nvSpPr>
@@ -4512,7 +4512,7 @@
                                           </p:stCondLst>
                                         </p:cTn>
                                         <p:tgtEl>
-                                          <p:spTgt spid="100215"/>
+                                          <p:spTgt spid="100213"/>
                                         </p:tgtEl>
                                         <p:attrNameLst>
                                           <p:attrName>style.visibility</p:attrName>
@@ -4526,7 +4526,7 @@
                                       <p:cBhvr>
                                         <p:cTn id="5" dur="400"/>
                                         <p:tgtEl>
-                                          <p:spTgt spid="100215"/>
+                                          <p:spTgt spid="100213"/>
                                         </p:tgtEl>
                                       </p:cBhvr>
                                     </p:animEffect>
@@ -4565,7 +4565,7 @@
                                           </p:stCondLst>
                                         </p:cTn>
                                         <p:tgtEl>
-                                          <p:spTgt spid="100218"/>
+                                          <p:spTgt spid="100216"/>
                                         </p:tgtEl>
                                         <p:attrNameLst>
                                           <p:attrName>style.visibility</p:attrName>
@@ -4579,7 +4579,7 @@
                                       <p:cBhvr>
                                         <p:cTn id="11" dur="450"/>
                                         <p:tgtEl>
-                                          <p:spTgt spid="100218"/>
+                                          <p:spTgt spid="100216"/>
                                         </p:tgtEl>
                                       </p:cBhvr>
                                     </p:animEffect>
@@ -4614,8 +4614,8 @@
       </p:par>
     </p:tnLst>
     <p:bldLst>
-      <p:bldP spid="100215" grpId="0"/>
-      <p:bldP spid="100218" grpId="1"/>
+      <p:bldP spid="100213" grpId="0"/>
+      <p:bldP spid="100216" grpId="1"/>
     </p:bldLst>
   </p:timing>
 </p:sld>
@@ -4640,7 +4640,7 @@
       <p:grpSpPr/>
       <p:sp>
         <p:nvSpPr>
-          <p:cNvPr id="100230" name="!!scene-orb-gold"/>
+          <p:cNvPr id="100228" name="!!scene-orb-gold"/>
           <p:cNvSpPr/>
           <p:nvPr/>
         </p:nvSpPr>
@@ -4677,7 +4677,7 @@
       </p:sp>
       <p:sp>
         <p:nvSpPr>
-          <p:cNvPr id="100231" name="!!scene-orb-steel"/>
+          <p:cNvPr id="100229" name="!!scene-orb-steel"/>
           <p:cNvSpPr/>
           <p:nvPr/>
         </p:nvSpPr>
@@ -4714,7 +4714,7 @@
       </p:sp>
       <p:sp>
         <p:nvSpPr>
-          <p:cNvPr id="100232" name="!!scene-wash"/>
+          <p:cNvPr id="100230" name="!!scene-wash"/>
           <p:cNvSpPr/>
           <p:nvPr/>
         </p:nvSpPr>
@@ -4745,7 +4745,7 @@
       </p:sp>
       <p:sp>
         <p:nvSpPr>
-          <p:cNvPr id="100233" name="!!scene-rule-navy"/>
+          <p:cNvPr id="100231" name="!!scene-rule-navy"/>
           <p:cNvSpPr/>
           <p:nvPr/>
         </p:nvSpPr>
@@ -4772,7 +4772,7 @@
       </p:sp>
       <p:sp>
         <p:nvSpPr>
-          <p:cNvPr id="100234" name="!!scene-rule-gold"/>
+          <p:cNvPr id="100232" name="!!scene-rule-gold"/>
           <p:cNvSpPr/>
           <p:nvPr/>
         </p:nvSpPr>
@@ -4799,7 +4799,7 @@
       </p:sp>
       <p:sp>
         <p:nvSpPr>
-          <p:cNvPr id="100235" name="!!scene-dot"/>
+          <p:cNvPr id="100233" name="!!scene-dot"/>
           <p:cNvSpPr/>
           <p:nvPr/>
         </p:nvSpPr>
@@ -4826,7 +4826,7 @@
       </p:sp>
       <p:sp>
         <p:nvSpPr>
-          <p:cNvPr id="100236" name="!!scene-footrule"/>
+          <p:cNvPr id="100234" name="!!scene-footrule"/>
           <p:cNvSpPr/>
           <p:nvPr/>
         </p:nvSpPr>
@@ -4853,7 +4853,7 @@
       </p:sp>
       <p:sp>
         <p:nvSpPr>
-          <p:cNvPr id="100237" name="!!#s13-eye-sec"/>
+          <p:cNvPr id="100235" name="!!#s13-eye-sec"/>
           <p:cNvSpPr txBox="1"/>
           <p:nvPr/>
         </p:nvSpPr>
@@ -4890,7 +4890,7 @@
       </p:sp>
       <p:sp>
         <p:nvSpPr>
-          <p:cNvPr id="100238" name="!!#s13-title"/>
+          <p:cNvPr id="100236" name="!!#s13-title"/>
           <p:cNvSpPr txBox="1"/>
           <p:nvPr/>
         </p:nvSpPr>
@@ -4927,7 +4927,7 @@
       </p:sp>
       <p:sp>
         <p:nvSpPr>
-          <p:cNvPr id="100239" name="!!#s13-eye-t0"/>
+          <p:cNvPr id="100237" name="!!#s13-eye-t0"/>
           <p:cNvSpPr txBox="1"/>
           <p:nvPr/>
         </p:nvSpPr>
@@ -4964,7 +4964,7 @@
       </p:sp>
       <p:sp>
         <p:nvSpPr>
-          <p:cNvPr id="100240" name="!!#s13-thead0"/>
+          <p:cNvPr id="100238" name="!!#s13-thead0"/>
           <p:cNvSpPr txBox="1"/>
           <p:nvPr/>
         </p:nvSpPr>
@@ -5001,7 +5001,7 @@
       </p:sp>
       <p:sp>
         <p:nvSpPr>
-          <p:cNvPr id="100241" name="!!#s13-tbody0"/>
+          <p:cNvPr id="100239" name="!!#s13-tbody0"/>
           <p:cNvSpPr txBox="1"/>
           <p:nvPr/>
         </p:nvSpPr>
@@ -5042,7 +5042,7 @@
       </p:sp>
       <p:sp>
         <p:nvSpPr>
-          <p:cNvPr id="100242" name="!!#s13-cell1"/>
+          <p:cNvPr id="100240" name="!!#s13-cell1"/>
           <p:cNvSpPr/>
           <p:nvPr/>
         </p:nvSpPr>
@@ -5073,7 +5073,7 @@
       </p:sp>
       <p:sp>
         <p:nvSpPr>
-          <p:cNvPr id="100243" name="!!#s13-eye-t1"/>
+          <p:cNvPr id="100241" name="!!#s13-eye-t1"/>
           <p:cNvSpPr txBox="1"/>
           <p:nvPr/>
         </p:nvSpPr>
@@ -5110,7 +5110,7 @@
       </p:sp>
       <p:sp>
         <p:nvSpPr>
-          <p:cNvPr id="100244" name="!!#s13-thead1"/>
+          <p:cNvPr id="100242" name="!!#s13-thead1"/>
           <p:cNvSpPr txBox="1"/>
           <p:nvPr/>
         </p:nvSpPr>
@@ -5147,7 +5147,7 @@
       </p:sp>
       <p:sp>
         <p:nvSpPr>
-          <p:cNvPr id="100245" name="!!#s13-tbody1"/>
+          <p:cNvPr id="100243" name="!!#s13-tbody1"/>
           <p:cNvSpPr txBox="1"/>
           <p:nvPr/>
         </p:nvSpPr>
@@ -5188,7 +5188,7 @@
       </p:sp>
       <p:sp>
         <p:nvSpPr>
-          <p:cNvPr id="100246" name="!!#s13-cell2"/>
+          <p:cNvPr id="100244" name="!!#s13-cell2"/>
           <p:cNvSpPr/>
           <p:nvPr/>
         </p:nvSpPr>
@@ -5219,7 +5219,7 @@
       </p:sp>
       <p:sp>
         <p:nvSpPr>
-          <p:cNvPr id="100247" name="!!#s13-eye-t2"/>
+          <p:cNvPr id="100245" name="!!#s13-eye-t2"/>
           <p:cNvSpPr txBox="1"/>
           <p:nvPr/>
         </p:nvSpPr>
@@ -5256,7 +5256,7 @@
       </p:sp>
       <p:sp>
         <p:nvSpPr>
-          <p:cNvPr id="100248" name="!!#s13-thead2"/>
+          <p:cNvPr id="100246" name="!!#s13-thead2"/>
           <p:cNvSpPr txBox="1"/>
           <p:nvPr/>
         </p:nvSpPr>
@@ -5293,7 +5293,7 @@
       </p:sp>
       <p:sp>
         <p:nvSpPr>
-          <p:cNvPr id="100249" name="!!#s13-tbody2"/>
+          <p:cNvPr id="100247" name="!!#s13-tbody2"/>
           <p:cNvSpPr txBox="1"/>
           <p:nvPr/>
         </p:nvSpPr>
@@ -5334,7 +5334,7 @@
       </p:sp>
       <p:sp>
         <p:nvSpPr>
-          <p:cNvPr id="100250" name="!!#s13-cell3"/>
+          <p:cNvPr id="100248" name="!!#s13-cell3"/>
           <p:cNvSpPr/>
           <p:nvPr/>
         </p:nvSpPr>
@@ -5365,7 +5365,7 @@
       </p:sp>
       <p:sp>
         <p:nvSpPr>
-          <p:cNvPr id="100251" name="!!#s13-eye-t3"/>
+          <p:cNvPr id="100249" name="!!#s13-eye-t3"/>
           <p:cNvSpPr txBox="1"/>
           <p:nvPr/>
         </p:nvSpPr>
@@ -5402,7 +5402,7 @@
       </p:sp>
       <p:sp>
         <p:nvSpPr>
-          <p:cNvPr id="100252" name="!!#s13-thead3"/>
+          <p:cNvPr id="100250" name="!!#s13-thead3"/>
           <p:cNvSpPr txBox="1"/>
           <p:nvPr/>
         </p:nvSpPr>
@@ -5439,7 +5439,7 @@
       </p:sp>
       <p:sp>
         <p:nvSpPr>
-          <p:cNvPr id="100253" name="!!#s13-tbody3"/>
+          <p:cNvPr id="100251" name="!!#s13-tbody3"/>
           <p:cNvSpPr txBox="1"/>
           <p:nvPr/>
         </p:nvSpPr>
@@ -5480,7 +5480,7 @@
       </p:sp>
       <p:sp>
         <p:nvSpPr>
-          <p:cNvPr id="100254" name="!!#s13-band"/>
+          <p:cNvPr id="100252" name="!!#s13-band"/>
           <p:cNvSpPr/>
           <p:nvPr/>
         </p:nvSpPr>
@@ -5511,7 +5511,7 @@
       </p:sp>
       <p:sp>
         <p:nvSpPr>
-          <p:cNvPr id="100255" name="!!#s13-bandfig"/>
+          <p:cNvPr id="100253" name="!!#s13-bandfig"/>
           <p:cNvSpPr txBox="1"/>
           <p:nvPr/>
         </p:nvSpPr>
@@ -5548,7 +5548,7 @@
       </p:sp>
       <p:sp>
         <p:nvSpPr>
-          <p:cNvPr id="100256" name="!!#s13-bandtxt"/>
+          <p:cNvPr id="100254" name="!!#s13-bandtxt"/>
           <p:cNvSpPr txBox="1"/>
           <p:nvPr/>
         </p:nvSpPr>
@@ -5589,7 +5589,7 @@
       </p:sp>
       <p:sp>
         <p:nvSpPr>
-          <p:cNvPr id="100257" name="!!#s13-foot"/>
+          <p:cNvPr id="100255" name="!!#s13-foot"/>
           <p:cNvSpPr txBox="1"/>
           <p:nvPr/>
         </p:nvSpPr>
@@ -5626,7 +5626,7 @@
       </p:sp>
       <p:sp>
         <p:nvSpPr>
-          <p:cNvPr id="100258" name="!!#s13-pageno"/>
+          <p:cNvPr id="100256" name="!!#s13-pageno"/>
           <p:cNvSpPr txBox="1"/>
           <p:nvPr/>
         </p:nvSpPr>
@@ -5709,7 +5709,7 @@
                                           </p:stCondLst>
                                         </p:cTn>
                                         <p:tgtEl>
-                                          <p:spTgt spid="100238"/>
+                                          <p:spTgt spid="100236"/>
                                         </p:tgtEl>
                                         <p:attrNameLst>
                                           <p:attrName>style.visibility</p:attrName>
@@ -5723,7 +5723,7 @@
                                       <p:cBhvr>
                                         <p:cTn id="5" dur="400"/>
                                         <p:tgtEl>
-                                          <p:spTgt spid="100238"/>
+                                          <p:spTgt spid="100236"/>
                                         </p:tgtEl>
                                       </p:cBhvr>
                                     </p:animEffect>
@@ -5762,7 +5762,7 @@
                                           </p:stCondLst>
                                         </p:cTn>
                                         <p:tgtEl>
-                                          <p:spTgt spid="100240"/>
+                                          <p:spTgt spid="100238"/>
                                         </p:tgtEl>
                                         <p:attrNameLst>
                                           <p:attrName>style.visibility</p:attrName>
@@ -5776,7 +5776,7 @@
                                       <p:cBhvr>
                                         <p:cTn id="11" dur="450"/>
                                         <p:tgtEl>
-                                          <p:spTgt spid="100240"/>
+                                          <p:spTgt spid="100238"/>
                                         </p:tgtEl>
                                       </p:cBhvr>
                                     </p:animEffect>
@@ -5811,8 +5811,8 @@
       </p:par>
     </p:tnLst>
     <p:bldLst>
-      <p:bldP spid="100238" grpId="0"/>
-      <p:bldP spid="100240" grpId="1"/>
+      <p:bldP spid="100236" grpId="0"/>
+      <p:bldP spid="100238" grpId="1"/>
     </p:bldLst>
   </p:timing>
 </p:sld>
@@ -5837,7 +5837,7 @@
       <p:grpSpPr/>
       <p:sp>
         <p:nvSpPr>
-          <p:cNvPr id="100259" name="!!scene-orb-gold"/>
+          <p:cNvPr id="100257" name="!!scene-orb-gold"/>
           <p:cNvSpPr/>
           <p:nvPr/>
         </p:nvSpPr>
@@ -5874,7 +5874,7 @@
       </p:sp>
       <p:sp>
         <p:nvSpPr>
-          <p:cNvPr id="100260" name="!!scene-orb-steel"/>
+          <p:cNvPr id="100258" name="!!scene-orb-steel"/>
           <p:cNvSpPr/>
           <p:nvPr/>
         </p:nvSpPr>
@@ -5911,7 +5911,7 @@
       </p:sp>
       <p:sp>
         <p:nvSpPr>
-          <p:cNvPr id="100261" name="!!scene-wash"/>
+          <p:cNvPr id="100259" name="!!scene-wash"/>
           <p:cNvSpPr/>
           <p:nvPr/>
         </p:nvSpPr>
@@ -5942,7 +5942,7 @@
       </p:sp>
       <p:sp>
         <p:nvSpPr>
-          <p:cNvPr id="100262" name="!!scene-rule-navy"/>
+          <p:cNvPr id="100260" name="!!scene-rule-navy"/>
           <p:cNvSpPr/>
           <p:nvPr/>
         </p:nvSpPr>
@@ -5969,7 +5969,7 @@
       </p:sp>
       <p:sp>
         <p:nvSpPr>
-          <p:cNvPr id="100263" name="!!scene-rule-gold"/>
+          <p:cNvPr id="100261" name="!!scene-rule-gold"/>
           <p:cNvSpPr/>
           <p:nvPr/>
         </p:nvSpPr>
@@ -5996,7 +5996,7 @@
       </p:sp>
       <p:sp>
         <p:nvSpPr>
-          <p:cNvPr id="100264" name="!!scene-dot"/>
+          <p:cNvPr id="100262" name="!!scene-dot"/>
           <p:cNvSpPr/>
           <p:nvPr/>
         </p:nvSpPr>
@@ -6023,7 +6023,7 @@
       </p:sp>
       <p:sp>
         <p:nvSpPr>
-          <p:cNvPr id="100265" name="!!scene-footrule"/>
+          <p:cNvPr id="100263" name="!!scene-footrule"/>
           <p:cNvSpPr/>
           <p:nvPr/>
         </p:nvSpPr>
@@ -6050,7 +6050,7 @@
       </p:sp>
       <p:sp>
         <p:nvSpPr>
-          <p:cNvPr id="100266" name="!!#s14-eye-sec"/>
+          <p:cNvPr id="100264" name="!!#s14-eye-sec"/>
           <p:cNvSpPr txBox="1"/>
           <p:nvPr/>
         </p:nvSpPr>
@@ -6087,7 +6087,7 @@
       </p:sp>
       <p:sp>
         <p:nvSpPr>
-          <p:cNvPr id="100267" name="!!#s14-title"/>
+          <p:cNvPr id="100265" name="!!#s14-title"/>
           <p:cNvSpPr txBox="1"/>
           <p:nvPr/>
         </p:nvSpPr>
@@ -6124,7 +6124,7 @@
       </p:sp>
       <p:sp>
         <p:nvSpPr>
-          <p:cNvPr id="100268" name="!!#s14-eye-c0"/>
+          <p:cNvPr id="100266" name="!!#s14-eye-c0"/>
           <p:cNvSpPr txBox="1"/>
           <p:nvPr/>
         </p:nvSpPr>
@@ -6161,7 +6161,7 @@
       </p:sp>
       <p:sp>
         <p:nvSpPr>
-          <p:cNvPr id="100269" name="!!#s14-chead0"/>
+          <p:cNvPr id="100267" name="!!#s14-chead0"/>
           <p:cNvSpPr txBox="1"/>
           <p:nvPr/>
         </p:nvSpPr>
@@ -6202,7 +6202,7 @@
       </p:sp>
       <p:sp>
         <p:nvSpPr>
-          <p:cNvPr id="100270" name="!!#s14-cbody0"/>
+          <p:cNvPr id="100268" name="!!#s14-cbody0"/>
           <p:cNvSpPr txBox="1"/>
           <p:nvPr/>
         </p:nvSpPr>
@@ -6243,7 +6243,7 @@
       </p:sp>
       <p:sp>
         <p:nvSpPr>
-          <p:cNvPr id="100271" name="!!#s14-card1"/>
+          <p:cNvPr id="100269" name="!!#s14-card1"/>
           <p:cNvSpPr/>
           <p:nvPr/>
         </p:nvSpPr>
@@ -6274,7 +6274,7 @@
       </p:sp>
       <p:sp>
         <p:nvSpPr>
-          <p:cNvPr id="100272" name="!!#s14-eye-c1"/>
+          <p:cNvPr id="100270" name="!!#s14-eye-c1"/>
           <p:cNvSpPr txBox="1"/>
           <p:nvPr/>
         </p:nvSpPr>
@@ -6311,7 +6311,7 @@
       </p:sp>
       <p:sp>
         <p:nvSpPr>
-          <p:cNvPr id="100273" name="!!#s14-chead1"/>
+          <p:cNvPr id="100271" name="!!#s14-chead1"/>
           <p:cNvSpPr txBox="1"/>
           <p:nvPr/>
         </p:nvSpPr>
@@ -6352,7 +6352,7 @@
       </p:sp>
       <p:sp>
         <p:nvSpPr>
-          <p:cNvPr id="100274" name="!!#s14-cbody1"/>
+          <p:cNvPr id="100272" name="!!#s14-cbody1"/>
           <p:cNvSpPr txBox="1"/>
           <p:nvPr/>
         </p:nvSpPr>
@@ -6393,7 +6393,7 @@
       </p:sp>
       <p:sp>
         <p:nvSpPr>
-          <p:cNvPr id="100275" name="!!#s14-card2"/>
+          <p:cNvPr id="100273" name="!!#s14-card2"/>
           <p:cNvSpPr/>
           <p:nvPr/>
         </p:nvSpPr>
@@ -6424,7 +6424,7 @@
       </p:sp>
       <p:sp>
         <p:nvSpPr>
-          <p:cNvPr id="100276" name="!!#s14-eye-c2"/>
+          <p:cNvPr id="100274" name="!!#s14-eye-c2"/>
           <p:cNvSpPr txBox="1"/>
           <p:nvPr/>
         </p:nvSpPr>
@@ -6461,7 +6461,7 @@
       </p:sp>
       <p:sp>
         <p:nvSpPr>
-          <p:cNvPr id="100277" name="!!#s14-chead2"/>
+          <p:cNvPr id="100275" name="!!#s14-chead2"/>
           <p:cNvSpPr txBox="1"/>
           <p:nvPr/>
         </p:nvSpPr>
@@ -6502,7 +6502,7 @@
       </p:sp>
       <p:sp>
         <p:nvSpPr>
-          <p:cNvPr id="100278" name="!!#s14-cbody2"/>
+          <p:cNvPr id="100276" name="!!#s14-cbody2"/>
           <p:cNvSpPr txBox="1"/>
           <p:nvPr/>
         </p:nvSpPr>
@@ -6543,7 +6543,7 @@
       </p:sp>
       <p:sp>
         <p:nvSpPr>
-          <p:cNvPr id="100279" name="!!#s14-foot"/>
+          <p:cNvPr id="100277" name="!!#s14-foot"/>
           <p:cNvSpPr txBox="1"/>
           <p:nvPr/>
         </p:nvSpPr>
@@ -6580,7 +6580,7 @@
       </p:sp>
       <p:sp>
         <p:nvSpPr>
-          <p:cNvPr id="100280" name="!!#s14-pageno"/>
+          <p:cNvPr id="100278" name="!!#s14-pageno"/>
           <p:cNvSpPr txBox="1"/>
           <p:nvPr/>
         </p:nvSpPr>
@@ -6663,7 +6663,7 @@
                                           </p:stCondLst>
                                         </p:cTn>
                                         <p:tgtEl>
-                                          <p:spTgt spid="100267"/>
+                                          <p:spTgt spid="100265"/>
                                         </p:tgtEl>
                                         <p:attrNameLst>
                                           <p:attrName>style.visibility</p:attrName>
@@ -6677,7 +6677,7 @@
                                       <p:cBhvr>
                                         <p:cTn id="5" dur="400"/>
                                         <p:tgtEl>
-                                          <p:spTgt spid="100267"/>
+                                          <p:spTgt spid="100265"/>
                                         </p:tgtEl>
                                       </p:cBhvr>
                                     </p:animEffect>
@@ -6716,7 +6716,7 @@
                                           </p:stCondLst>
                                         </p:cTn>
                                         <p:tgtEl>
-                                          <p:spTgt spid="100269"/>
+                                          <p:spTgt spid="100267"/>
                                         </p:tgtEl>
                                         <p:attrNameLst>
                                           <p:attrName>style.visibility</p:attrName>
@@ -6730,7 +6730,7 @@
                                       <p:cBhvr>
                                         <p:cTn id="11" dur="450"/>
                                         <p:tgtEl>
-                                          <p:spTgt spid="100269"/>
+                                          <p:spTgt spid="100267"/>
                                         </p:tgtEl>
                                       </p:cBhvr>
                                     </p:animEffect>
@@ -6765,8 +6765,8 @@
       </p:par>
     </p:tnLst>
     <p:bldLst>
-      <p:bldP spid="100267" grpId="0"/>
-      <p:bldP spid="100269" grpId="1"/>
+      <p:bldP spid="100265" grpId="0"/>
+      <p:bldP spid="100267" grpId="1"/>
     </p:bldLst>
   </p:timing>
 </p:sld>
@@ -6791,7 +6791,7 @@
       <p:grpSpPr/>
       <p:sp>
         <p:nvSpPr>
-          <p:cNvPr id="100281" name="!!scene-orb-gold"/>
+          <p:cNvPr id="100279" name="!!scene-orb-gold"/>
           <p:cNvSpPr/>
           <p:nvPr/>
         </p:nvSpPr>
@@ -6828,7 +6828,7 @@
       </p:sp>
       <p:sp>
         <p:nvSpPr>
-          <p:cNvPr id="100282" name="!!scene-orb-steel"/>
+          <p:cNvPr id="100280" name="!!scene-orb-steel"/>
           <p:cNvSpPr/>
           <p:nvPr/>
         </p:nvSpPr>
@@ -6865,7 +6865,7 @@
       </p:sp>
       <p:sp>
         <p:nvSpPr>
-          <p:cNvPr id="100283" name="!!scene-wash"/>
+          <p:cNvPr id="100281" name="!!scene-wash"/>
           <p:cNvSpPr/>
           <p:nvPr/>
         </p:nvSpPr>
@@ -6896,7 +6896,7 @@
       </p:sp>
       <p:sp>
         <p:nvSpPr>
-          <p:cNvPr id="100284" name="!!scene-rule-navy"/>
+          <p:cNvPr id="100282" name="!!scene-rule-navy"/>
           <p:cNvSpPr/>
           <p:nvPr/>
         </p:nvSpPr>
@@ -6923,7 +6923,7 @@
       </p:sp>
       <p:sp>
         <p:nvSpPr>
-          <p:cNvPr id="100285" name="!!scene-rule-gold"/>
+          <p:cNvPr id="100283" name="!!scene-rule-gold"/>
           <p:cNvSpPr/>
           <p:nvPr/>
         </p:nvSpPr>
@@ -6950,7 +6950,7 @@
       </p:sp>
       <p:sp>
         <p:nvSpPr>
-          <p:cNvPr id="100286" name="!!scene-dot"/>
+          <p:cNvPr id="100284" name="!!scene-dot"/>
           <p:cNvSpPr/>
           <p:nvPr/>
         </p:nvSpPr>
@@ -6977,7 +6977,7 @@
       </p:sp>
       <p:sp>
         <p:nvSpPr>
-          <p:cNvPr id="100287" name="!!scene-footrule"/>
+          <p:cNvPr id="100285" name="!!scene-footrule"/>
           <p:cNvSpPr/>
           <p:nvPr/>
         </p:nvSpPr>
@@ -7004,7 +7004,7 @@
       </p:sp>
       <p:sp>
         <p:nvSpPr>
-          <p:cNvPr id="100288" name="!!#s15-eye-sec"/>
+          <p:cNvPr id="100286" name="!!#s15-eye-sec"/>
           <p:cNvSpPr txBox="1"/>
           <p:nvPr/>
         </p:nvSpPr>
@@ -7041,7 +7041,7 @@
       </p:sp>
       <p:sp>
         <p:nvSpPr>
-          <p:cNvPr id="100289" name="!!#s15-title"/>
+          <p:cNvPr id="100287" name="!!#s15-title"/>
           <p:cNvSpPr txBox="1"/>
           <p:nvPr/>
         </p:nvSpPr>
@@ -7078,7 +7078,7 @@
       </p:sp>
       <p:sp>
         <p:nvSpPr>
-          <p:cNvPr id="100290" name="!!#s15-pull"/>
+          <p:cNvPr id="100288" name="!!#s15-pull"/>
           <p:cNvSpPr txBox="1"/>
           <p:nvPr/>
         </p:nvSpPr>
@@ -7119,7 +7119,7 @@
       </p:sp>
       <p:sp>
         <p:nvSpPr>
-          <p:cNvPr id="100291" name="!!#s15-pdiv"/>
+          <p:cNvPr id="100289" name="!!#s15-pdiv"/>
           <p:cNvSpPr/>
           <p:nvPr/>
         </p:nvSpPr>
@@ -7146,7 +7146,7 @@
       </p:sp>
       <p:sp>
         <p:nvSpPr>
-          <p:cNvPr id="100292" name="!!#s15-eye-pr0"/>
+          <p:cNvPr id="100290" name="!!#s15-eye-pr0"/>
           <p:cNvSpPr txBox="1"/>
           <p:nvPr/>
         </p:nvSpPr>
@@ -7176,14 +7176,14 @@
                 <a:latin typeface="Arial"/>
                 <a:ea typeface="Arial"/>
               </a:rPr>
-              <a:t>MANAGING PARTNER</a:t>
-            </a:r>
-          </a:p>
-        </p:txBody>
-      </p:sp>
-      <p:sp>
-        <p:nvSpPr>
-          <p:cNvPr id="100293" name="!!#s15-pname0"/>
+              <a:t>PARTNER</a:t>
+            </a:r>
+          </a:p>
+        </p:txBody>
+      </p:sp>
+      <p:sp>
+        <p:nvSpPr>
+          <p:cNvPr id="100291" name="!!#s15-pname0"/>
           <p:cNvSpPr txBox="1"/>
           <p:nvPr/>
         </p:nvSpPr>
@@ -7213,14 +7213,14 @@
                 <a:latin typeface="Georgia"/>
                 <a:ea typeface="Georgia"/>
               </a:rPr>
-              <a:t>HK Vinay</a:t>
-            </a:r>
-          </a:p>
-        </p:txBody>
-      </p:sp>
-      <p:sp>
-        <p:nvSpPr>
-          <p:cNvPr id="100294" name="!!#s15-ptick0"/>
+              <a:t>Shabari</a:t>
+            </a:r>
+          </a:p>
+        </p:txBody>
+      </p:sp>
+      <p:sp>
+        <p:nvSpPr>
+          <p:cNvPr id="100292" name="!!#s15-ptick0"/>
           <p:cNvSpPr/>
           <p:nvPr/>
         </p:nvSpPr>
@@ -7247,7 +7247,7 @@
       </p:sp>
       <p:sp>
         <p:nvSpPr>
-          <p:cNvPr id="100295" name="!!#s15-pcard1"/>
+          <p:cNvPr id="100293" name="!!#s15-pcard1"/>
           <p:cNvSpPr/>
           <p:nvPr/>
         </p:nvSpPr>
@@ -7278,7 +7278,7 @@
       </p:sp>
       <p:sp>
         <p:nvSpPr>
-          <p:cNvPr id="100296" name="!!#s15-eye-pr1"/>
+          <p:cNvPr id="100294" name="!!#s15-eye-pr1"/>
           <p:cNvSpPr txBox="1"/>
           <p:nvPr/>
         </p:nvSpPr>
@@ -7308,14 +7308,14 @@
                 <a:latin typeface="Arial"/>
                 <a:ea typeface="Arial"/>
               </a:rPr>
-              <a:t>PARTNER</a:t>
-            </a:r>
-          </a:p>
-        </p:txBody>
-      </p:sp>
-      <p:sp>
-        <p:nvSpPr>
-          <p:cNvPr id="100297" name="!!#s15-pname1"/>
+              <a:t>MANAGING PARTNER</a:t>
+            </a:r>
+          </a:p>
+        </p:txBody>
+      </p:sp>
+      <p:sp>
+        <p:nvSpPr>
+          <p:cNvPr id="100295" name="!!#s15-pname1"/>
           <p:cNvSpPr txBox="1"/>
           <p:nvPr/>
         </p:nvSpPr>
@@ -7345,14 +7345,14 @@
                 <a:latin typeface="Georgia"/>
                 <a:ea typeface="Georgia"/>
               </a:rPr>
-              <a:t>Shabari</a:t>
-            </a:r>
-          </a:p>
-        </p:txBody>
-      </p:sp>
-      <p:sp>
-        <p:nvSpPr>
-          <p:cNvPr id="100298" name="!!#s15-ptick1"/>
+              <a:t>HK Vinay</a:t>
+            </a:r>
+          </a:p>
+        </p:txBody>
+      </p:sp>
+      <p:sp>
+        <p:nvSpPr>
+          <p:cNvPr id="100296" name="!!#s15-ptick1"/>
           <p:cNvSpPr/>
           <p:nvPr/>
         </p:nvSpPr>
@@ -7379,7 +7379,7 @@
       </p:sp>
       <p:sp>
         <p:nvSpPr>
-          <p:cNvPr id="100299" name="!!#s15-pcard2"/>
+          <p:cNvPr id="100297" name="!!#s15-pcard2"/>
           <p:cNvSpPr/>
           <p:nvPr/>
         </p:nvSpPr>
@@ -7410,7 +7410,7 @@
       </p:sp>
       <p:sp>
         <p:nvSpPr>
-          <p:cNvPr id="100300" name="!!#s15-eye-pr2"/>
+          <p:cNvPr id="100298" name="!!#s15-eye-pr2"/>
           <p:cNvSpPr txBox="1"/>
           <p:nvPr/>
         </p:nvSpPr>
@@ -7447,7 +7447,7 @@
       </p:sp>
       <p:sp>
         <p:nvSpPr>
-          <p:cNvPr id="100301" name="!!#s15-pname2"/>
+          <p:cNvPr id="100299" name="!!#s15-pname2"/>
           <p:cNvSpPr txBox="1"/>
           <p:nvPr/>
         </p:nvSpPr>
@@ -7484,7 +7484,7 @@
       </p:sp>
       <p:sp>
         <p:nvSpPr>
-          <p:cNvPr id="100302" name="!!#s15-ptick2"/>
+          <p:cNvPr id="100300" name="!!#s15-ptick2"/>
           <p:cNvSpPr/>
           <p:nvPr/>
         </p:nvSpPr>
@@ -7511,7 +7511,7 @@
       </p:sp>
       <p:sp>
         <p:nvSpPr>
-          <p:cNvPr id="100303" name="!!#s15-pcard3"/>
+          <p:cNvPr id="100301" name="!!#s15-pcard3"/>
           <p:cNvSpPr/>
           <p:nvPr/>
         </p:nvSpPr>
@@ -7542,7 +7542,7 @@
       </p:sp>
       <p:sp>
         <p:nvSpPr>
-          <p:cNvPr id="100304" name="!!#s15-eye-pr3"/>
+          <p:cNvPr id="100302" name="!!#s15-eye-pr3"/>
           <p:cNvSpPr txBox="1"/>
           <p:nvPr/>
         </p:nvSpPr>
@@ -7579,7 +7579,7 @@
       </p:sp>
       <p:sp>
         <p:nvSpPr>
-          <p:cNvPr id="100305" name="!!#s15-pname3"/>
+          <p:cNvPr id="100303" name="!!#s15-pname3"/>
           <p:cNvSpPr txBox="1"/>
           <p:nvPr/>
         </p:nvSpPr>
@@ -7616,7 +7616,7 @@
       </p:sp>
       <p:sp>
         <p:nvSpPr>
-          <p:cNvPr id="100306" name="!!#s15-ptick3"/>
+          <p:cNvPr id="100304" name="!!#s15-ptick3"/>
           <p:cNvSpPr/>
           <p:nvPr/>
         </p:nvSpPr>
@@ -7643,7 +7643,7 @@
       </p:sp>
       <p:sp>
         <p:nvSpPr>
-          <p:cNvPr id="100307" name="!!#s15-band"/>
+          <p:cNvPr id="100305" name="!!#s15-band"/>
           <p:cNvSpPr/>
           <p:nvPr/>
         </p:nvSpPr>
@@ -7674,7 +7674,7 @@
       </p:sp>
       <p:sp>
         <p:nvSpPr>
-          <p:cNvPr id="100308" name="!!#s15-bandtxt"/>
+          <p:cNvPr id="100306" name="!!#s15-bandtxt"/>
           <p:cNvSpPr txBox="1"/>
           <p:nvPr/>
         </p:nvSpPr>
@@ -7715,7 +7715,7 @@
       </p:sp>
       <p:sp>
         <p:nvSpPr>
-          <p:cNvPr id="100309" name="!!#s15-foot"/>
+          <p:cNvPr id="100307" name="!!#s15-foot"/>
           <p:cNvSpPr txBox="1"/>
           <p:nvPr/>
         </p:nvSpPr>
@@ -7752,7 +7752,7 @@
       </p:sp>
       <p:sp>
         <p:nvSpPr>
-          <p:cNvPr id="100310" name="!!#s15-pageno"/>
+          <p:cNvPr id="100308" name="!!#s15-pageno"/>
           <p:cNvSpPr txBox="1"/>
           <p:nvPr/>
         </p:nvSpPr>
@@ -7835,7 +7835,7 @@
                                           </p:stCondLst>
                                         </p:cTn>
                                         <p:tgtEl>
-                                          <p:spTgt spid="100289"/>
+                                          <p:spTgt spid="100287"/>
                                         </p:tgtEl>
                                         <p:attrNameLst>
                                           <p:attrName>style.visibility</p:attrName>
@@ -7849,7 +7849,7 @@
                                       <p:cBhvr>
                                         <p:cTn id="5" dur="400"/>
                                         <p:tgtEl>
-                                          <p:spTgt spid="100289"/>
+                                          <p:spTgt spid="100287"/>
                                         </p:tgtEl>
                                       </p:cBhvr>
                                     </p:animEffect>
@@ -7888,7 +7888,7 @@
                                           </p:stCondLst>
                                         </p:cTn>
                                         <p:tgtEl>
-                                          <p:spTgt spid="100290"/>
+                                          <p:spTgt spid="100288"/>
                                         </p:tgtEl>
                                         <p:attrNameLst>
                                           <p:attrName>style.visibility</p:attrName>
@@ -7902,7 +7902,7 @@
                                       <p:cBhvr>
                                         <p:cTn id="11" dur="500"/>
                                         <p:tgtEl>
-                                          <p:spTgt spid="100290"/>
+                                          <p:spTgt spid="100288"/>
                                         </p:tgtEl>
                                       </p:cBhvr>
                                     </p:animEffect>
@@ -7937,8 +7937,8 @@
       </p:par>
     </p:tnLst>
     <p:bldLst>
-      <p:bldP spid="100289" grpId="0"/>
-      <p:bldP spid="100290" grpId="1"/>
+      <p:bldP spid="100287" grpId="0"/>
+      <p:bldP spid="100288" grpId="1"/>
     </p:bldLst>
   </p:timing>
 </p:sld>
@@ -7963,7 +7963,7 @@
       <p:grpSpPr/>
       <p:sp>
         <p:nvSpPr>
-          <p:cNvPr id="100311" name="!!scene-orb-gold"/>
+          <p:cNvPr id="100309" name="!!scene-orb-gold"/>
           <p:cNvSpPr/>
           <p:nvPr/>
         </p:nvSpPr>
@@ -8000,7 +8000,7 @@
       </p:sp>
       <p:sp>
         <p:nvSpPr>
-          <p:cNvPr id="100312" name="!!scene-orb-steel"/>
+          <p:cNvPr id="100310" name="!!scene-orb-steel"/>
           <p:cNvSpPr/>
           <p:nvPr/>
         </p:nvSpPr>
@@ -8037,7 +8037,7 @@
       </p:sp>
       <p:sp>
         <p:nvSpPr>
-          <p:cNvPr id="100313" name="!!scene-wash"/>
+          <p:cNvPr id="100311" name="!!scene-wash"/>
           <p:cNvSpPr/>
           <p:nvPr/>
         </p:nvSpPr>
@@ -8068,7 +8068,7 @@
       </p:sp>
       <p:sp>
         <p:nvSpPr>
-          <p:cNvPr id="100314" name="!!scene-rule-navy"/>
+          <p:cNvPr id="100312" name="!!scene-rule-navy"/>
           <p:cNvSpPr/>
           <p:nvPr/>
         </p:nvSpPr>
@@ -8095,7 +8095,7 @@
       </p:sp>
       <p:sp>
         <p:nvSpPr>
-          <p:cNvPr id="100315" name="!!scene-rule-gold"/>
+          <p:cNvPr id="100313" name="!!scene-rule-gold"/>
           <p:cNvSpPr/>
           <p:nvPr/>
         </p:nvSpPr>
@@ -8122,7 +8122,7 @@
       </p:sp>
       <p:sp>
         <p:nvSpPr>
-          <p:cNvPr id="100316" name="!!scene-dot"/>
+          <p:cNvPr id="100314" name="!!scene-dot"/>
           <p:cNvSpPr/>
           <p:nvPr/>
         </p:nvSpPr>
@@ -8149,7 +8149,7 @@
       </p:sp>
       <p:sp>
         <p:nvSpPr>
-          <p:cNvPr id="100317" name="!!scene-footrule"/>
+          <p:cNvPr id="100315" name="!!scene-footrule"/>
           <p:cNvSpPr/>
           <p:nvPr/>
         </p:nvSpPr>
@@ -8176,7 +8176,7 @@
       </p:sp>
       <p:sp>
         <p:nvSpPr>
-          <p:cNvPr id="100318" name="!!#s16-eye-sec"/>
+          <p:cNvPr id="100316" name="!!#s16-eye-sec"/>
           <p:cNvSpPr txBox="1"/>
           <p:nvPr/>
         </p:nvSpPr>
@@ -8213,7 +8213,7 @@
       </p:sp>
       <p:sp>
         <p:nvSpPr>
-          <p:cNvPr id="100319" name="!!#s16-title"/>
+          <p:cNvPr id="100317" name="!!#s16-title"/>
           <p:cNvSpPr txBox="1"/>
           <p:nvPr/>
         </p:nvSpPr>
@@ -8250,7 +8250,7 @@
       </p:sp>
       <p:sp>
         <p:nvSpPr>
-          <p:cNvPr id="100320" name="!!#s16-eye-c0"/>
+          <p:cNvPr id="100318" name="!!#s16-eye-c0"/>
           <p:cNvSpPr txBox="1"/>
           <p:nvPr/>
         </p:nvSpPr>
@@ -8287,7 +8287,7 @@
       </p:sp>
       <p:sp>
         <p:nvSpPr>
-          <p:cNvPr id="100321" name="!!#s16-chead0"/>
+          <p:cNvPr id="100319" name="!!#s16-chead0"/>
           <p:cNvSpPr txBox="1"/>
           <p:nvPr/>
         </p:nvSpPr>
@@ -8328,7 +8328,7 @@
       </p:sp>
       <p:sp>
         <p:nvSpPr>
-          <p:cNvPr id="100322" name="!!#s16-cbody0"/>
+          <p:cNvPr id="100320" name="!!#s16-cbody0"/>
           <p:cNvSpPr txBox="1"/>
           <p:nvPr/>
         </p:nvSpPr>
@@ -8369,7 +8369,7 @@
       </p:sp>
       <p:sp>
         <p:nvSpPr>
-          <p:cNvPr id="100323" name="!!#s16-card1"/>
+          <p:cNvPr id="100321" name="!!#s16-card1"/>
           <p:cNvSpPr/>
           <p:nvPr/>
         </p:nvSpPr>
@@ -8400,7 +8400,7 @@
       </p:sp>
       <p:sp>
         <p:nvSpPr>
-          <p:cNvPr id="100324" name="!!#s16-eye-c1"/>
+          <p:cNvPr id="100322" name="!!#s16-eye-c1"/>
           <p:cNvSpPr txBox="1"/>
           <p:nvPr/>
         </p:nvSpPr>
@@ -8437,7 +8437,7 @@
       </p:sp>
       <p:sp>
         <p:nvSpPr>
-          <p:cNvPr id="100325" name="!!#s16-chead1"/>
+          <p:cNvPr id="100323" name="!!#s16-chead1"/>
           <p:cNvSpPr txBox="1"/>
           <p:nvPr/>
         </p:nvSpPr>
@@ -8478,7 +8478,7 @@
       </p:sp>
       <p:sp>
         <p:nvSpPr>
-          <p:cNvPr id="100326" name="!!#s16-cbody1"/>
+          <p:cNvPr id="100324" name="!!#s16-cbody1"/>
           <p:cNvSpPr txBox="1"/>
           <p:nvPr/>
         </p:nvSpPr>
@@ -8519,7 +8519,7 @@
       </p:sp>
       <p:sp>
         <p:nvSpPr>
-          <p:cNvPr id="100327" name="!!#s16-card2"/>
+          <p:cNvPr id="100325" name="!!#s16-card2"/>
           <p:cNvSpPr/>
           <p:nvPr/>
         </p:nvSpPr>
@@ -8550,7 +8550,7 @@
       </p:sp>
       <p:sp>
         <p:nvSpPr>
-          <p:cNvPr id="100328" name="!!#s16-eye-c2"/>
+          <p:cNvPr id="100326" name="!!#s16-eye-c2"/>
           <p:cNvSpPr txBox="1"/>
           <p:nvPr/>
         </p:nvSpPr>
@@ -8587,7 +8587,7 @@
       </p:sp>
       <p:sp>
         <p:nvSpPr>
-          <p:cNvPr id="100329" name="!!#s16-chead2"/>
+          <p:cNvPr id="100327" name="!!#s16-chead2"/>
           <p:cNvSpPr txBox="1"/>
           <p:nvPr/>
         </p:nvSpPr>
@@ -8628,7 +8628,7 @@
       </p:sp>
       <p:sp>
         <p:nvSpPr>
-          <p:cNvPr id="100330" name="!!#s16-cbody2"/>
+          <p:cNvPr id="100328" name="!!#s16-cbody2"/>
           <p:cNvSpPr txBox="1"/>
           <p:nvPr/>
         </p:nvSpPr>
@@ -8669,7 +8669,7 @@
       </p:sp>
       <p:sp>
         <p:nvSpPr>
-          <p:cNvPr id="100331" name="!!#s16-ctdiv"/>
+          <p:cNvPr id="100329" name="!!#s16-ctdiv"/>
           <p:cNvSpPr/>
           <p:nvPr/>
         </p:nvSpPr>
@@ -8696,14 +8696,14 @@
       </p:sp>
       <p:sp>
         <p:nvSpPr>
-          <p:cNvPr id="100332" name="!!#s16-eye-ct0"/>
+          <p:cNvPr id="100330" name="!!#s16-eye-ct0"/>
           <p:cNvSpPr txBox="1"/>
           <p:nvPr/>
         </p:nvSpPr>
         <p:spPr>
           <a:xfrm xmlns:a="http://schemas.openxmlformats.org/drawingml/2006/main">
             <a:off x="684000" y="5094000"/>
-            <a:ext cx="2700000" cy="252000"/>
+            <a:ext cx="3391200" cy="252000"/>
           </a:xfrm>
           <a:prstGeom xmlns:a="http://schemas.openxmlformats.org/drawingml/2006/main" prst="rect">
             <a:avLst/>
@@ -8733,14 +8733,14 @@
       </p:sp>
       <p:sp>
         <p:nvSpPr>
-          <p:cNvPr id="100333" name="!!#s16-contact0"/>
+          <p:cNvPr id="100331" name="!!#s16-contact0"/>
           <p:cNvSpPr txBox="1"/>
           <p:nvPr/>
         </p:nvSpPr>
         <p:spPr>
           <a:xfrm xmlns:a="http://schemas.openxmlformats.org/drawingml/2006/main">
             <a:off x="684000" y="5364000"/>
-            <a:ext cx="2700000" cy="576000"/>
+            <a:ext cx="3391200" cy="576000"/>
           </a:xfrm>
           <a:prstGeom xmlns:a="http://schemas.openxmlformats.org/drawingml/2006/main" prst="rect">
             <a:avLst/>
@@ -8774,14 +8774,14 @@
       </p:sp>
       <p:sp>
         <p:nvSpPr>
-          <p:cNvPr id="100334" name="!!#s16-eye-ct1"/>
-          <p:cNvSpPr txBox="1"/>
-          <p:nvPr/>
-        </p:nvSpPr>
-        <p:spPr>
-          <a:xfrm xmlns:a="http://schemas.openxmlformats.org/drawingml/2006/main">
-            <a:off x="3672000" y="5094000"/>
-            <a:ext cx="2700000" cy="252000"/>
+          <p:cNvPr id="100332" name="!!#s16-eye-ct1"/>
+          <p:cNvSpPr txBox="1"/>
+          <p:nvPr/>
+        </p:nvSpPr>
+        <p:spPr>
+          <a:xfrm xmlns:a="http://schemas.openxmlformats.org/drawingml/2006/main">
+            <a:off x="4399200" y="5094000"/>
+            <a:ext cx="3391200" cy="252000"/>
           </a:xfrm>
           <a:prstGeom xmlns:a="http://schemas.openxmlformats.org/drawingml/2006/main" prst="rect">
             <a:avLst/>
@@ -8811,14 +8811,14 @@
       </p:sp>
       <p:sp>
         <p:nvSpPr>
-          <p:cNvPr id="100335" name="!!#s16-contact1"/>
-          <p:cNvSpPr txBox="1"/>
-          <p:nvPr/>
-        </p:nvSpPr>
-        <p:spPr>
-          <a:xfrm xmlns:a="http://schemas.openxmlformats.org/drawingml/2006/main">
-            <a:off x="3672000" y="5364000"/>
-            <a:ext cx="2700000" cy="576000"/>
+          <p:cNvPr id="100333" name="!!#s16-contact1"/>
+          <p:cNvSpPr txBox="1"/>
+          <p:nvPr/>
+        </p:nvSpPr>
+        <p:spPr>
+          <a:xfrm xmlns:a="http://schemas.openxmlformats.org/drawingml/2006/main">
+            <a:off x="4399200" y="5364000"/>
+            <a:ext cx="3391200" cy="576000"/>
           </a:xfrm>
           <a:prstGeom xmlns:a="http://schemas.openxmlformats.org/drawingml/2006/main" prst="rect">
             <a:avLst/>
@@ -8869,14 +8869,14 @@
       </p:sp>
       <p:sp>
         <p:nvSpPr>
-          <p:cNvPr id="100336" name="!!#s16-eye-ct2"/>
-          <p:cNvSpPr txBox="1"/>
-          <p:nvPr/>
-        </p:nvSpPr>
-        <p:spPr>
-          <a:xfrm xmlns:a="http://schemas.openxmlformats.org/drawingml/2006/main">
-            <a:off x="6696000" y="5094000"/>
-            <a:ext cx="4813200" cy="252000"/>
+          <p:cNvPr id="100334" name="!!#s16-eye-ct2"/>
+          <p:cNvSpPr txBox="1"/>
+          <p:nvPr/>
+        </p:nvSpPr>
+        <p:spPr>
+          <a:xfrm xmlns:a="http://schemas.openxmlformats.org/drawingml/2006/main">
+            <a:off x="8118000" y="5094000"/>
+            <a:ext cx="3391200" cy="252000"/>
           </a:xfrm>
           <a:prstGeom xmlns:a="http://schemas.openxmlformats.org/drawingml/2006/main" prst="rect">
             <a:avLst/>
@@ -8906,14 +8906,14 @@
       </p:sp>
       <p:sp>
         <p:nvSpPr>
-          <p:cNvPr id="100337" name="!!#s16-contact2"/>
-          <p:cNvSpPr txBox="1"/>
-          <p:nvPr/>
-        </p:nvSpPr>
-        <p:spPr>
-          <a:xfrm xmlns:a="http://schemas.openxmlformats.org/drawingml/2006/main">
-            <a:off x="6696000" y="5364000"/>
-            <a:ext cx="4813200" cy="576000"/>
+          <p:cNvPr id="100335" name="!!#s16-contact2"/>
+          <p:cNvSpPr txBox="1"/>
+          <p:nvPr/>
+        </p:nvSpPr>
+        <p:spPr>
+          <a:xfrm xmlns:a="http://schemas.openxmlformats.org/drawingml/2006/main">
+            <a:off x="8118000" y="5364000"/>
+            <a:ext cx="3391200" cy="576000"/>
           </a:xfrm>
           <a:prstGeom xmlns:a="http://schemas.openxmlformats.org/drawingml/2006/main" prst="rect">
             <a:avLst/>
@@ -8940,7 +8940,7 @@
                 <a:latin typeface="Arial"/>
                 <a:ea typeface="Arial"/>
               </a:rPr>
-              <a:t>cavinaykarlagere@twchartered.com</a:t>
+              <a:t>cahkv@twchartered.com</a:t>
             </a:r>
           </a:p>
           <a:p xmlns:a="http://schemas.openxmlformats.org/drawingml/2006/main">
@@ -8964,7 +8964,7 @@
       </p:sp>
       <p:sp>
         <p:nvSpPr>
-          <p:cNvPr id="100338" name="!!#s16-foot"/>
+          <p:cNvPr id="100336" name="!!#s16-foot"/>
           <p:cNvSpPr txBox="1"/>
           <p:nvPr/>
         </p:nvSpPr>
@@ -9001,7 +9001,7 @@
       </p:sp>
       <p:sp>
         <p:nvSpPr>
-          <p:cNvPr id="100339" name="!!#s16-pageno"/>
+          <p:cNvPr id="100337" name="!!#s16-pageno"/>
           <p:cNvSpPr txBox="1"/>
           <p:nvPr/>
         </p:nvSpPr>
@@ -9084,7 +9084,7 @@
                                           </p:stCondLst>
                                         </p:cTn>
                                         <p:tgtEl>
-                                          <p:spTgt spid="100319"/>
+                                          <p:spTgt spid="100317"/>
                                         </p:tgtEl>
                                         <p:attrNameLst>
                                           <p:attrName>style.visibility</p:attrName>
@@ -9098,7 +9098,7 @@
                                       <p:cBhvr>
                                         <p:cTn id="5" dur="400"/>
                                         <p:tgtEl>
-                                          <p:spTgt spid="100319"/>
+                                          <p:spTgt spid="100317"/>
                                         </p:tgtEl>
                                       </p:cBhvr>
                                     </p:animEffect>
@@ -9137,7 +9137,7 @@
                                           </p:stCondLst>
                                         </p:cTn>
                                         <p:tgtEl>
-                                          <p:spTgt spid="100321"/>
+                                          <p:spTgt spid="100319"/>
                                         </p:tgtEl>
                                         <p:attrNameLst>
                                           <p:attrName>style.visibility</p:attrName>
@@ -9151,7 +9151,7 @@
                                       <p:cBhvr>
                                         <p:cTn id="11" dur="450"/>
                                         <p:tgtEl>
-                                          <p:spTgt spid="100321"/>
+                                          <p:spTgt spid="100319"/>
                                         </p:tgtEl>
                                       </p:cBhvr>
                                     </p:animEffect>
@@ -9186,8 +9186,8 @@
       </p:par>
     </p:tnLst>
     <p:bldLst>
-      <p:bldP spid="100319" grpId="0"/>
-      <p:bldP spid="100321" grpId="1"/>
+      <p:bldP spid="100317" grpId="0"/>
+      <p:bldP spid="100319" grpId="1"/>
     </p:bldLst>
   </p:timing>
 </p:sld>
@@ -9730,7 +9730,7 @@
         <p:spPr>
           <a:xfrm xmlns:a="http://schemas.openxmlformats.org/drawingml/2006/main">
             <a:off x="936000" y="4752000"/>
-            <a:ext cx="2210400" cy="630000"/>
+            <a:ext cx="3139200" cy="630000"/>
           </a:xfrm>
           <a:prstGeom xmlns:a="http://schemas.openxmlformats.org/drawingml/2006/main" prst="rect">
             <a:avLst/>
@@ -9767,7 +9767,7 @@
         <p:spPr>
           <a:xfrm xmlns:a="http://schemas.openxmlformats.org/drawingml/2006/main">
             <a:off x="936000" y="5454000"/>
-            <a:ext cx="2210400" cy="252000"/>
+            <a:ext cx="3139200" cy="252000"/>
           </a:xfrm>
           <a:prstGeom xmlns:a="http://schemas.openxmlformats.org/drawingml/2006/main" prst="rect">
             <a:avLst/>
@@ -9803,8 +9803,8 @@
         </p:nvSpPr>
         <p:spPr>
           <a:xfrm xmlns:a="http://schemas.openxmlformats.org/drawingml/2006/main">
-            <a:off x="3722400" y="4752000"/>
-            <a:ext cx="2210400" cy="630000"/>
+            <a:off x="4651200" y="4752000"/>
+            <a:ext cx="3139200" cy="630000"/>
           </a:xfrm>
           <a:prstGeom xmlns:a="http://schemas.openxmlformats.org/drawingml/2006/main" prst="rect">
             <a:avLst/>
@@ -9840,8 +9840,8 @@
         </p:nvSpPr>
         <p:spPr>
           <a:xfrm xmlns:a="http://schemas.openxmlformats.org/drawingml/2006/main">
-            <a:off x="3722400" y="5454000"/>
-            <a:ext cx="2210400" cy="252000"/>
+            <a:off x="4651200" y="5454000"/>
+            <a:ext cx="3139200" cy="252000"/>
           </a:xfrm>
           <a:prstGeom xmlns:a="http://schemas.openxmlformats.org/drawingml/2006/main" prst="rect">
             <a:avLst/>
@@ -9877,8 +9877,8 @@
         </p:nvSpPr>
         <p:spPr>
           <a:xfrm xmlns:a="http://schemas.openxmlformats.org/drawingml/2006/main">
-            <a:off x="6508800" y="4752000"/>
-            <a:ext cx="2210400" cy="630000"/>
+            <a:off x="8370000" y="4752000"/>
+            <a:ext cx="3139200" cy="630000"/>
           </a:xfrm>
           <a:prstGeom xmlns:a="http://schemas.openxmlformats.org/drawingml/2006/main" prst="rect">
             <a:avLst/>
@@ -9914,8 +9914,8 @@
         </p:nvSpPr>
         <p:spPr>
           <a:xfrm xmlns:a="http://schemas.openxmlformats.org/drawingml/2006/main">
-            <a:off x="6508800" y="5454000"/>
-            <a:ext cx="2210400" cy="252000"/>
+            <a:off x="8370000" y="5454000"/>
+            <a:ext cx="3139200" cy="252000"/>
           </a:xfrm>
           <a:prstGeom xmlns:a="http://schemas.openxmlformats.org/drawingml/2006/main" prst="rect">
             <a:avLst/>
@@ -9945,110 +9945,36 @@
       </p:sp>
       <p:sp>
         <p:nvSpPr>
-          <p:cNvPr id="100032" name="!!#s2-kpi3"/>
-          <p:cNvSpPr txBox="1"/>
-          <p:nvPr/>
-        </p:nvSpPr>
-        <p:spPr>
-          <a:xfrm xmlns:a="http://schemas.openxmlformats.org/drawingml/2006/main">
-            <a:off x="9298800" y="4752000"/>
-            <a:ext cx="2210400" cy="630000"/>
-          </a:xfrm>
-          <a:prstGeom xmlns:a="http://schemas.openxmlformats.org/drawingml/2006/main" prst="rect">
-            <a:avLst/>
-          </a:prstGeom>
-          <a:noFill xmlns:a="http://schemas.openxmlformats.org/drawingml/2006/main"/>
-          <a:ln xmlns:a="http://schemas.openxmlformats.org/drawingml/2006/main">
-            <a:noFill/>
-          </a:ln>
-        </p:spPr>
-        <p:txBody>
-          <a:bodyPr xmlns:a="http://schemas.openxmlformats.org/drawingml/2006/main" lIns="0" tIns="0" rIns="0" bIns="0" anchor="ctr"/>
+          <p:cNvPr id="100032" name="!!#s2-foot"/>
+          <p:cNvSpPr txBox="1"/>
+          <p:nvPr/>
+        </p:nvSpPr>
+        <p:spPr>
+          <a:xfrm xmlns:a="http://schemas.openxmlformats.org/drawingml/2006/main">
+            <a:off x="684000" y="6246000"/>
+            <a:ext cx="7200000" cy="198000"/>
+          </a:xfrm>
+          <a:prstGeom xmlns:a="http://schemas.openxmlformats.org/drawingml/2006/main" prst="rect">
+            <a:avLst/>
+          </a:prstGeom>
+          <a:noFill xmlns:a="http://schemas.openxmlformats.org/drawingml/2006/main"/>
+          <a:ln xmlns:a="http://schemas.openxmlformats.org/drawingml/2006/main">
+            <a:noFill/>
+          </a:ln>
+        </p:spPr>
+        <p:txBody>
+          <a:bodyPr xmlns:a="http://schemas.openxmlformats.org/drawingml/2006/main" lIns="0" tIns="0" rIns="0" bIns="0" anchor="t"/>
           <a:lstStyle xmlns:a="http://schemas.openxmlformats.org/drawingml/2006/main"/>
           <a:p xmlns:a="http://schemas.openxmlformats.org/drawingml/2006/main">
             <a:pPr algn="l"/>
             <a:r>
-              <a:rPr lang="en-US" sz="4000" b="1">
-                <a:solidFill>
-                  <a:srgbClr val="C9A84C"/>
-                </a:solidFill>
-                <a:latin typeface="Georgia"/>
-                <a:ea typeface="Georgia"/>
-              </a:rPr>
-              <a:t>50 Cr+</a:t>
-            </a:r>
-          </a:p>
-        </p:txBody>
-      </p:sp>
-      <p:sp>
-        <p:nvSpPr>
-          <p:cNvPr id="100033" name="!!#s2-kpisub3"/>
-          <p:cNvSpPr txBox="1"/>
-          <p:nvPr/>
-        </p:nvSpPr>
-        <p:spPr>
-          <a:xfrm xmlns:a="http://schemas.openxmlformats.org/drawingml/2006/main">
-            <a:off x="9298800" y="5454000"/>
-            <a:ext cx="2210400" cy="252000"/>
-          </a:xfrm>
-          <a:prstGeom xmlns:a="http://schemas.openxmlformats.org/drawingml/2006/main" prst="rect">
-            <a:avLst/>
-          </a:prstGeom>
-          <a:noFill xmlns:a="http://schemas.openxmlformats.org/drawingml/2006/main"/>
-          <a:ln xmlns:a="http://schemas.openxmlformats.org/drawingml/2006/main">
-            <a:noFill/>
-          </a:ln>
-        </p:spPr>
-        <p:txBody>
-          <a:bodyPr xmlns:a="http://schemas.openxmlformats.org/drawingml/2006/main" lIns="0" tIns="0" rIns="0" bIns="0" anchor="t"/>
-          <a:lstStyle xmlns:a="http://schemas.openxmlformats.org/drawingml/2006/main"/>
-          <a:p xmlns:a="http://schemas.openxmlformats.org/drawingml/2006/main">
-            <a:pPr algn="l"/>
-            <a:r>
-              <a:rPr lang="en-US" sz="1200" spc="80">
+              <a:rPr lang="en-US" sz="1000" spc="140">
                 <a:solidFill>
                   <a:srgbClr val="8A9BBF"/>
                 </a:solidFill>
                 <a:latin typeface="Arial"/>
                 <a:ea typeface="Arial"/>
               </a:rPr>
-              <a:t>Rupees saved in tax</a:t>
-            </a:r>
-          </a:p>
-        </p:txBody>
-      </p:sp>
-      <p:sp>
-        <p:nvSpPr>
-          <p:cNvPr id="100034" name="!!#s2-foot"/>
-          <p:cNvSpPr txBox="1"/>
-          <p:nvPr/>
-        </p:nvSpPr>
-        <p:spPr>
-          <a:xfrm xmlns:a="http://schemas.openxmlformats.org/drawingml/2006/main">
-            <a:off x="684000" y="6246000"/>
-            <a:ext cx="7200000" cy="198000"/>
-          </a:xfrm>
-          <a:prstGeom xmlns:a="http://schemas.openxmlformats.org/drawingml/2006/main" prst="rect">
-            <a:avLst/>
-          </a:prstGeom>
-          <a:noFill xmlns:a="http://schemas.openxmlformats.org/drawingml/2006/main"/>
-          <a:ln xmlns:a="http://schemas.openxmlformats.org/drawingml/2006/main">
-            <a:noFill/>
-          </a:ln>
-        </p:spPr>
-        <p:txBody>
-          <a:bodyPr xmlns:a="http://schemas.openxmlformats.org/drawingml/2006/main" lIns="0" tIns="0" rIns="0" bIns="0" anchor="t"/>
-          <a:lstStyle xmlns:a="http://schemas.openxmlformats.org/drawingml/2006/main"/>
-          <a:p xmlns:a="http://schemas.openxmlformats.org/drawingml/2006/main">
-            <a:pPr algn="l"/>
-            <a:r>
-              <a:rPr lang="en-US" sz="1000" spc="140">
-                <a:solidFill>
-                  <a:srgbClr val="8A9BBF"/>
-                </a:solidFill>
-                <a:latin typeface="Arial"/>
-                <a:ea typeface="Arial"/>
-              </a:rPr>
               <a:t>TaxWise Consultants  ·  Singapore Practice</a:t>
             </a:r>
           </a:p>
@@ -10056,7 +9982,7 @@
       </p:sp>
       <p:sp>
         <p:nvSpPr>
-          <p:cNvPr id="100035" name="!!#s2-pageno"/>
+          <p:cNvPr id="100033" name="!!#s2-pageno"/>
           <p:cNvSpPr txBox="1"/>
           <p:nvPr/>
         </p:nvSpPr>
@@ -10267,7 +10193,7 @@
       <p:grpSpPr/>
       <p:sp>
         <p:nvSpPr>
-          <p:cNvPr id="100036" name="!!scene-orb-gold"/>
+          <p:cNvPr id="100034" name="!!scene-orb-gold"/>
           <p:cNvSpPr/>
           <p:nvPr/>
         </p:nvSpPr>
@@ -10304,7 +10230,7 @@
       </p:sp>
       <p:sp>
         <p:nvSpPr>
-          <p:cNvPr id="100037" name="!!scene-orb-steel"/>
+          <p:cNvPr id="100035" name="!!scene-orb-steel"/>
           <p:cNvSpPr/>
           <p:nvPr/>
         </p:nvSpPr>
@@ -10341,7 +10267,7 @@
       </p:sp>
       <p:sp>
         <p:nvSpPr>
-          <p:cNvPr id="100038" name="!!scene-wash"/>
+          <p:cNvPr id="100036" name="!!scene-wash"/>
           <p:cNvSpPr/>
           <p:nvPr/>
         </p:nvSpPr>
@@ -10372,7 +10298,7 @@
       </p:sp>
       <p:sp>
         <p:nvSpPr>
-          <p:cNvPr id="100039" name="!!scene-rule-navy"/>
+          <p:cNvPr id="100037" name="!!scene-rule-navy"/>
           <p:cNvSpPr/>
           <p:nvPr/>
         </p:nvSpPr>
@@ -10399,7 +10325,7 @@
       </p:sp>
       <p:sp>
         <p:nvSpPr>
-          <p:cNvPr id="100040" name="!!scene-rule-gold"/>
+          <p:cNvPr id="100038" name="!!scene-rule-gold"/>
           <p:cNvSpPr/>
           <p:nvPr/>
         </p:nvSpPr>
@@ -10426,7 +10352,7 @@
       </p:sp>
       <p:sp>
         <p:nvSpPr>
-          <p:cNvPr id="100041" name="!!scene-dot"/>
+          <p:cNvPr id="100039" name="!!scene-dot"/>
           <p:cNvSpPr/>
           <p:nvPr/>
         </p:nvSpPr>
@@ -10453,7 +10379,7 @@
       </p:sp>
       <p:sp>
         <p:nvSpPr>
-          <p:cNvPr id="100042" name="!!scene-footrule"/>
+          <p:cNvPr id="100040" name="!!scene-footrule"/>
           <p:cNvSpPr/>
           <p:nvPr/>
         </p:nvSpPr>
@@ -10480,7 +10406,7 @@
       </p:sp>
       <p:sp>
         <p:nvSpPr>
-          <p:cNvPr id="100043" name="!!#s3-eye-sec"/>
+          <p:cNvPr id="100041" name="!!#s3-eye-sec"/>
           <p:cNvSpPr txBox="1"/>
           <p:nvPr/>
         </p:nvSpPr>
@@ -10517,7 +10443,7 @@
       </p:sp>
       <p:sp>
         <p:nvSpPr>
-          <p:cNvPr id="100044" name="!!#s3-title"/>
+          <p:cNvPr id="100042" name="!!#s3-title"/>
           <p:cNvSpPr txBox="1"/>
           <p:nvPr/>
         </p:nvSpPr>
@@ -10554,7 +10480,7 @@
       </p:sp>
       <p:sp>
         <p:nvSpPr>
-          <p:cNvPr id="100045" name="!!#s3-eye-c0"/>
+          <p:cNvPr id="100043" name="!!#s3-eye-c0"/>
           <p:cNvSpPr txBox="1"/>
           <p:nvPr/>
         </p:nvSpPr>
@@ -10591,7 +10517,7 @@
       </p:sp>
       <p:sp>
         <p:nvSpPr>
-          <p:cNvPr id="100046" name="!!#s3-chead0"/>
+          <p:cNvPr id="100044" name="!!#s3-chead0"/>
           <p:cNvSpPr txBox="1"/>
           <p:nvPr/>
         </p:nvSpPr>
@@ -10632,7 +10558,7 @@
       </p:sp>
       <p:sp>
         <p:nvSpPr>
-          <p:cNvPr id="100047" name="!!#s3-cbody0"/>
+          <p:cNvPr id="100045" name="!!#s3-cbody0"/>
           <p:cNvSpPr txBox="1"/>
           <p:nvPr/>
         </p:nvSpPr>
@@ -10673,7 +10599,7 @@
       </p:sp>
       <p:sp>
         <p:nvSpPr>
-          <p:cNvPr id="100048" name="!!#s3-card1"/>
+          <p:cNvPr id="100046" name="!!#s3-card1"/>
           <p:cNvSpPr/>
           <p:nvPr/>
         </p:nvSpPr>
@@ -10704,7 +10630,7 @@
       </p:sp>
       <p:sp>
         <p:nvSpPr>
-          <p:cNvPr id="100049" name="!!#s3-eye-c1"/>
+          <p:cNvPr id="100047" name="!!#s3-eye-c1"/>
           <p:cNvSpPr txBox="1"/>
           <p:nvPr/>
         </p:nvSpPr>
@@ -10741,7 +10667,7 @@
       </p:sp>
       <p:sp>
         <p:nvSpPr>
-          <p:cNvPr id="100050" name="!!#s3-chead1"/>
+          <p:cNvPr id="100048" name="!!#s3-chead1"/>
           <p:cNvSpPr txBox="1"/>
           <p:nvPr/>
         </p:nvSpPr>
@@ -10782,7 +10708,7 @@
       </p:sp>
       <p:sp>
         <p:nvSpPr>
-          <p:cNvPr id="100051" name="!!#s3-cbody1"/>
+          <p:cNvPr id="100049" name="!!#s3-cbody1"/>
           <p:cNvSpPr txBox="1"/>
           <p:nvPr/>
         </p:nvSpPr>
@@ -10823,7 +10749,7 @@
       </p:sp>
       <p:sp>
         <p:nvSpPr>
-          <p:cNvPr id="100052" name="!!#s3-card2"/>
+          <p:cNvPr id="100050" name="!!#s3-card2"/>
           <p:cNvSpPr/>
           <p:nvPr/>
         </p:nvSpPr>
@@ -10854,7 +10780,7 @@
       </p:sp>
       <p:sp>
         <p:nvSpPr>
-          <p:cNvPr id="100053" name="!!#s3-eye-c2"/>
+          <p:cNvPr id="100051" name="!!#s3-eye-c2"/>
           <p:cNvSpPr txBox="1"/>
           <p:nvPr/>
         </p:nvSpPr>
@@ -10891,7 +10817,7 @@
       </p:sp>
       <p:sp>
         <p:nvSpPr>
-          <p:cNvPr id="100054" name="!!#s3-chead2"/>
+          <p:cNvPr id="100052" name="!!#s3-chead2"/>
           <p:cNvSpPr txBox="1"/>
           <p:nvPr/>
         </p:nvSpPr>
@@ -10932,7 +10858,7 @@
       </p:sp>
       <p:sp>
         <p:nvSpPr>
-          <p:cNvPr id="100055" name="!!#s3-cbody2"/>
+          <p:cNvPr id="100053" name="!!#s3-cbody2"/>
           <p:cNvSpPr txBox="1"/>
           <p:nvPr/>
         </p:nvSpPr>
@@ -10973,7 +10899,7 @@
       </p:sp>
       <p:sp>
         <p:nvSpPr>
-          <p:cNvPr id="100056" name="!!#s3-foot"/>
+          <p:cNvPr id="100054" name="!!#s3-foot"/>
           <p:cNvSpPr txBox="1"/>
           <p:nvPr/>
         </p:nvSpPr>
@@ -11010,7 +10936,7 @@
       </p:sp>
       <p:sp>
         <p:nvSpPr>
-          <p:cNvPr id="100057" name="!!#s3-pageno"/>
+          <p:cNvPr id="100055" name="!!#s3-pageno"/>
           <p:cNvSpPr txBox="1"/>
           <p:nvPr/>
         </p:nvSpPr>
@@ -11093,7 +11019,7 @@
                                           </p:stCondLst>
                                         </p:cTn>
                                         <p:tgtEl>
-                                          <p:spTgt spid="100044"/>
+                                          <p:spTgt spid="100042"/>
                                         </p:tgtEl>
                                         <p:attrNameLst>
                                           <p:attrName>style.visibility</p:attrName>
@@ -11107,7 +11033,7 @@
                                       <p:cBhvr>
                                         <p:cTn id="5" dur="400"/>
                                         <p:tgtEl>
-                                          <p:spTgt spid="100044"/>
+                                          <p:spTgt spid="100042"/>
                                         </p:tgtEl>
                                       </p:cBhvr>
                                     </p:animEffect>
@@ -11146,7 +11072,7 @@
                                           </p:stCondLst>
                                         </p:cTn>
                                         <p:tgtEl>
-                                          <p:spTgt spid="100046"/>
+                                          <p:spTgt spid="100044"/>
                                         </p:tgtEl>
                                         <p:attrNameLst>
                                           <p:attrName>style.visibility</p:attrName>
@@ -11160,7 +11086,7 @@
                                       <p:cBhvr>
                                         <p:cTn id="11" dur="450"/>
                                         <p:tgtEl>
-                                          <p:spTgt spid="100046"/>
+                                          <p:spTgt spid="100044"/>
                                         </p:tgtEl>
                                       </p:cBhvr>
                                     </p:animEffect>
@@ -11195,8 +11121,8 @@
       </p:par>
     </p:tnLst>
     <p:bldLst>
-      <p:bldP spid="100044" grpId="0"/>
-      <p:bldP spid="100046" grpId="1"/>
+      <p:bldP spid="100042" grpId="0"/>
+      <p:bldP spid="100044" grpId="1"/>
     </p:bldLst>
   </p:timing>
 </p:sld>
@@ -11221,7 +11147,7 @@
       <p:grpSpPr/>
       <p:sp>
         <p:nvSpPr>
-          <p:cNvPr id="100058" name="!!scene-orb-gold"/>
+          <p:cNvPr id="100056" name="!!scene-orb-gold"/>
           <p:cNvSpPr/>
           <p:nvPr/>
         </p:nvSpPr>
@@ -11258,7 +11184,7 @@
       </p:sp>
       <p:sp>
         <p:nvSpPr>
-          <p:cNvPr id="100059" name="!!scene-orb-steel"/>
+          <p:cNvPr id="100057" name="!!scene-orb-steel"/>
           <p:cNvSpPr/>
           <p:nvPr/>
         </p:nvSpPr>
@@ -11295,7 +11221,7 @@
       </p:sp>
       <p:sp>
         <p:nvSpPr>
-          <p:cNvPr id="100060" name="!!scene-wash"/>
+          <p:cNvPr id="100058" name="!!scene-wash"/>
           <p:cNvSpPr/>
           <p:nvPr/>
         </p:nvSpPr>
@@ -11326,7 +11252,7 @@
       </p:sp>
       <p:sp>
         <p:nvSpPr>
-          <p:cNvPr id="100061" name="!!scene-rule-navy"/>
+          <p:cNvPr id="100059" name="!!scene-rule-navy"/>
           <p:cNvSpPr/>
           <p:nvPr/>
         </p:nvSpPr>
@@ -11353,7 +11279,7 @@
       </p:sp>
       <p:sp>
         <p:nvSpPr>
-          <p:cNvPr id="100062" name="!!scene-rule-gold"/>
+          <p:cNvPr id="100060" name="!!scene-rule-gold"/>
           <p:cNvSpPr/>
           <p:nvPr/>
         </p:nvSpPr>
@@ -11380,7 +11306,7 @@
       </p:sp>
       <p:sp>
         <p:nvSpPr>
-          <p:cNvPr id="100063" name="!!scene-dot"/>
+          <p:cNvPr id="100061" name="!!scene-dot"/>
           <p:cNvSpPr/>
           <p:nvPr/>
         </p:nvSpPr>
@@ -11407,7 +11333,7 @@
       </p:sp>
       <p:sp>
         <p:nvSpPr>
-          <p:cNvPr id="100064" name="!!#s4-topbar"/>
+          <p:cNvPr id="100062" name="!!#s4-topbar"/>
           <p:cNvSpPr txBox="1"/>
           <p:nvPr/>
         </p:nvSpPr>
@@ -11444,7 +11370,7 @@
       </p:sp>
       <p:sp>
         <p:nvSpPr>
-          <p:cNvPr id="100065" name="!!#s4-num"/>
+          <p:cNvPr id="100063" name="!!#s4-num"/>
           <p:cNvSpPr txBox="1"/>
           <p:nvPr/>
         </p:nvSpPr>
@@ -11481,7 +11407,7 @@
       </p:sp>
       <p:sp>
         <p:nvSpPr>
-          <p:cNvPr id="100066" name="!!#s4-title"/>
+          <p:cNvPr id="100064" name="!!#s4-title"/>
           <p:cNvSpPr txBox="1"/>
           <p:nvPr/>
         </p:nvSpPr>
@@ -11518,7 +11444,7 @@
       </p:sp>
       <p:sp>
         <p:nvSpPr>
-          <p:cNvPr id="100067" name="!!#s4-strap"/>
+          <p:cNvPr id="100065" name="!!#s4-strap"/>
           <p:cNvSpPr txBox="1"/>
           <p:nvPr/>
         </p:nvSpPr>
@@ -11605,7 +11531,7 @@
                                           </p:stCondLst>
                                         </p:cTn>
                                         <p:tgtEl>
-                                          <p:spTgt spid="100066"/>
+                                          <p:spTgt spid="100064"/>
                                         </p:tgtEl>
                                         <p:attrNameLst>
                                           <p:attrName>style.visibility</p:attrName>
@@ -11619,7 +11545,7 @@
                                       <p:cBhvr>
                                         <p:cTn id="5" dur="400"/>
                                         <p:tgtEl>
-                                          <p:spTgt spid="100066"/>
+                                          <p:spTgt spid="100064"/>
                                         </p:tgtEl>
                                       </p:cBhvr>
                                     </p:animEffect>
@@ -11658,7 +11584,7 @@
                                           </p:stCondLst>
                                         </p:cTn>
                                         <p:tgtEl>
-                                          <p:spTgt spid="100065"/>
+                                          <p:spTgt spid="100063"/>
                                         </p:tgtEl>
                                         <p:attrNameLst>
                                           <p:attrName>style.visibility</p:attrName>
@@ -11672,7 +11598,7 @@
                                       <p:cBhvr>
                                         <p:cTn id="11" dur="500"/>
                                         <p:tgtEl>
-                                          <p:spTgt spid="100065"/>
+                                          <p:spTgt spid="100063"/>
                                         </p:tgtEl>
                                       </p:cBhvr>
                                     </p:animEffect>
@@ -11707,8 +11633,8 @@
       </p:par>
     </p:tnLst>
     <p:bldLst>
-      <p:bldP spid="100066" grpId="0"/>
-      <p:bldP spid="100065" grpId="1"/>
+      <p:bldP spid="100064" grpId="0"/>
+      <p:bldP spid="100063" grpId="1"/>
     </p:bldLst>
   </p:timing>
 </p:sld>
@@ -11733,7 +11659,7 @@
       <p:grpSpPr/>
       <p:sp>
         <p:nvSpPr>
-          <p:cNvPr id="100068" name="!!scene-orb-gold"/>
+          <p:cNvPr id="100066" name="!!scene-orb-gold"/>
           <p:cNvSpPr/>
           <p:nvPr/>
         </p:nvSpPr>
@@ -11770,7 +11696,7 @@
       </p:sp>
       <p:sp>
         <p:nvSpPr>
-          <p:cNvPr id="100069" name="!!scene-orb-steel"/>
+          <p:cNvPr id="100067" name="!!scene-orb-steel"/>
           <p:cNvSpPr/>
           <p:nvPr/>
         </p:nvSpPr>
@@ -11807,7 +11733,7 @@
       </p:sp>
       <p:sp>
         <p:nvSpPr>
-          <p:cNvPr id="100070" name="!!scene-wash"/>
+          <p:cNvPr id="100068" name="!!scene-wash"/>
           <p:cNvSpPr/>
           <p:nvPr/>
         </p:nvSpPr>
@@ -11838,7 +11764,7 @@
       </p:sp>
       <p:sp>
         <p:nvSpPr>
-          <p:cNvPr id="100071" name="!!scene-rule-navy"/>
+          <p:cNvPr id="100069" name="!!scene-rule-navy"/>
           <p:cNvSpPr/>
           <p:nvPr/>
         </p:nvSpPr>
@@ -11865,7 +11791,7 @@
       </p:sp>
       <p:sp>
         <p:nvSpPr>
-          <p:cNvPr id="100072" name="!!scene-rule-gold"/>
+          <p:cNvPr id="100070" name="!!scene-rule-gold"/>
           <p:cNvSpPr/>
           <p:nvPr/>
         </p:nvSpPr>
@@ -11892,7 +11818,7 @@
       </p:sp>
       <p:sp>
         <p:nvSpPr>
-          <p:cNvPr id="100073" name="!!scene-dot"/>
+          <p:cNvPr id="100071" name="!!scene-dot"/>
           <p:cNvSpPr/>
           <p:nvPr/>
         </p:nvSpPr>
@@ -11919,7 +11845,7 @@
       </p:sp>
       <p:sp>
         <p:nvSpPr>
-          <p:cNvPr id="100074" name="!!scene-footrule"/>
+          <p:cNvPr id="100072" name="!!scene-footrule"/>
           <p:cNvSpPr/>
           <p:nvPr/>
         </p:nvSpPr>
@@ -11946,7 +11872,7 @@
       </p:sp>
       <p:sp>
         <p:nvSpPr>
-          <p:cNvPr id="100075" name="!!#s5-eye-sec"/>
+          <p:cNvPr id="100073" name="!!#s5-eye-sec"/>
           <p:cNvSpPr txBox="1"/>
           <p:nvPr/>
         </p:nvSpPr>
@@ -11983,7 +11909,7 @@
       </p:sp>
       <p:sp>
         <p:nvSpPr>
-          <p:cNvPr id="100076" name="!!#s5-title"/>
+          <p:cNvPr id="100074" name="!!#s5-title"/>
           <p:cNvSpPr txBox="1"/>
           <p:nvPr/>
         </p:nvSpPr>
@@ -12020,7 +11946,7 @@
       </p:sp>
       <p:sp>
         <p:nvSpPr>
-          <p:cNvPr id="100077" name="!!#s5-eye-c0"/>
+          <p:cNvPr id="100075" name="!!#s5-eye-c0"/>
           <p:cNvSpPr txBox="1"/>
           <p:nvPr/>
         </p:nvSpPr>
@@ -12057,7 +11983,7 @@
       </p:sp>
       <p:sp>
         <p:nvSpPr>
-          <p:cNvPr id="100078" name="!!#s5-chead0"/>
+          <p:cNvPr id="100076" name="!!#s5-chead0"/>
           <p:cNvSpPr txBox="1"/>
           <p:nvPr/>
         </p:nvSpPr>
@@ -12098,7 +12024,7 @@
       </p:sp>
       <p:sp>
         <p:nvSpPr>
-          <p:cNvPr id="100079" name="!!#s5-cbody0"/>
+          <p:cNvPr id="100077" name="!!#s5-cbody0"/>
           <p:cNvSpPr txBox="1"/>
           <p:nvPr/>
         </p:nvSpPr>
@@ -12139,7 +12065,7 @@
       </p:sp>
       <p:sp>
         <p:nvSpPr>
-          <p:cNvPr id="100080" name="!!#s5-card1"/>
+          <p:cNvPr id="100078" name="!!#s5-card1"/>
           <p:cNvSpPr/>
           <p:nvPr/>
         </p:nvSpPr>
@@ -12170,7 +12096,7 @@
       </p:sp>
       <p:sp>
         <p:nvSpPr>
-          <p:cNvPr id="100081" name="!!#s5-eye-c1"/>
+          <p:cNvPr id="100079" name="!!#s5-eye-c1"/>
           <p:cNvSpPr txBox="1"/>
           <p:nvPr/>
         </p:nvSpPr>
@@ -12207,7 +12133,7 @@
       </p:sp>
       <p:sp>
         <p:nvSpPr>
-          <p:cNvPr id="100082" name="!!#s5-chead1"/>
+          <p:cNvPr id="100080" name="!!#s5-chead1"/>
           <p:cNvSpPr txBox="1"/>
           <p:nvPr/>
         </p:nvSpPr>
@@ -12248,7 +12174,7 @@
       </p:sp>
       <p:sp>
         <p:nvSpPr>
-          <p:cNvPr id="100083" name="!!#s5-cbody1"/>
+          <p:cNvPr id="100081" name="!!#s5-cbody1"/>
           <p:cNvSpPr txBox="1"/>
           <p:nvPr/>
         </p:nvSpPr>
@@ -12289,7 +12215,7 @@
       </p:sp>
       <p:sp>
         <p:nvSpPr>
-          <p:cNvPr id="100084" name="!!#s5-card2"/>
+          <p:cNvPr id="100082" name="!!#s5-card2"/>
           <p:cNvSpPr/>
           <p:nvPr/>
         </p:nvSpPr>
@@ -12320,7 +12246,7 @@
       </p:sp>
       <p:sp>
         <p:nvSpPr>
-          <p:cNvPr id="100085" name="!!#s5-eye-c2"/>
+          <p:cNvPr id="100083" name="!!#s5-eye-c2"/>
           <p:cNvSpPr txBox="1"/>
           <p:nvPr/>
         </p:nvSpPr>
@@ -12357,7 +12283,7 @@
       </p:sp>
       <p:sp>
         <p:nvSpPr>
-          <p:cNvPr id="100086" name="!!#s5-chead2"/>
+          <p:cNvPr id="100084" name="!!#s5-chead2"/>
           <p:cNvSpPr txBox="1"/>
           <p:nvPr/>
         </p:nvSpPr>
@@ -12398,7 +12324,7 @@
       </p:sp>
       <p:sp>
         <p:nvSpPr>
-          <p:cNvPr id="100087" name="!!#s5-cbody2"/>
+          <p:cNvPr id="100085" name="!!#s5-cbody2"/>
           <p:cNvSpPr txBox="1"/>
           <p:nvPr/>
         </p:nvSpPr>
@@ -12439,7 +12365,7 @@
       </p:sp>
       <p:sp>
         <p:nvSpPr>
-          <p:cNvPr id="100088" name="!!#s5-foot"/>
+          <p:cNvPr id="100086" name="!!#s5-foot"/>
           <p:cNvSpPr txBox="1"/>
           <p:nvPr/>
         </p:nvSpPr>
@@ -12476,7 +12402,7 @@
       </p:sp>
       <p:sp>
         <p:nvSpPr>
-          <p:cNvPr id="100089" name="!!#s5-pageno"/>
+          <p:cNvPr id="100087" name="!!#s5-pageno"/>
           <p:cNvSpPr txBox="1"/>
           <p:nvPr/>
         </p:nvSpPr>
@@ -12559,7 +12485,7 @@
                                           </p:stCondLst>
                                         </p:cTn>
                                         <p:tgtEl>
-                                          <p:spTgt spid="100076"/>
+                                          <p:spTgt spid="100074"/>
                                         </p:tgtEl>
                                         <p:attrNameLst>
                                           <p:attrName>style.visibility</p:attrName>
@@ -12573,7 +12499,7 @@
                                       <p:cBhvr>
                                         <p:cTn id="5" dur="400"/>
                                         <p:tgtEl>
-                                          <p:spTgt spid="100076"/>
+                                          <p:spTgt spid="100074"/>
                                         </p:tgtEl>
                                       </p:cBhvr>
                                     </p:animEffect>
@@ -12612,7 +12538,7 @@
                                           </p:stCondLst>
                                         </p:cTn>
                                         <p:tgtEl>
-                                          <p:spTgt spid="100078"/>
+                                          <p:spTgt spid="100076"/>
                                         </p:tgtEl>
                                         <p:attrNameLst>
                                           <p:attrName>style.visibility</p:attrName>
@@ -12626,7 +12552,7 @@
                                       <p:cBhvr>
                                         <p:cTn id="11" dur="450"/>
                                         <p:tgtEl>
-                                          <p:spTgt spid="100078"/>
+                                          <p:spTgt spid="100076"/>
                                         </p:tgtEl>
                                       </p:cBhvr>
                                     </p:animEffect>
@@ -12661,8 +12587,8 @@
       </p:par>
     </p:tnLst>
     <p:bldLst>
-      <p:bldP spid="100076" grpId="0"/>
-      <p:bldP spid="100078" grpId="1"/>
+      <p:bldP spid="100074" grpId="0"/>
+      <p:bldP spid="100076" grpId="1"/>
     </p:bldLst>
   </p:timing>
 </p:sld>
@@ -12687,7 +12613,7 @@
       <p:grpSpPr/>
       <p:sp>
         <p:nvSpPr>
-          <p:cNvPr id="100090" name="!!scene-orb-gold"/>
+          <p:cNvPr id="100088" name="!!scene-orb-gold"/>
           <p:cNvSpPr/>
           <p:nvPr/>
         </p:nvSpPr>
@@ -12724,7 +12650,7 @@
       </p:sp>
       <p:sp>
         <p:nvSpPr>
-          <p:cNvPr id="100091" name="!!scene-orb-steel"/>
+          <p:cNvPr id="100089" name="!!scene-orb-steel"/>
           <p:cNvSpPr/>
           <p:nvPr/>
         </p:nvSpPr>
@@ -12761,7 +12687,7 @@
       </p:sp>
       <p:sp>
         <p:nvSpPr>
-          <p:cNvPr id="100092" name="!!scene-wash"/>
+          <p:cNvPr id="100090" name="!!scene-wash"/>
           <p:cNvSpPr/>
           <p:nvPr/>
         </p:nvSpPr>
@@ -12792,7 +12718,7 @@
       </p:sp>
       <p:sp>
         <p:nvSpPr>
-          <p:cNvPr id="100093" name="!!scene-rule-navy"/>
+          <p:cNvPr id="100091" name="!!scene-rule-navy"/>
           <p:cNvSpPr/>
           <p:nvPr/>
         </p:nvSpPr>
@@ -12819,7 +12745,7 @@
       </p:sp>
       <p:sp>
         <p:nvSpPr>
-          <p:cNvPr id="100094" name="!!scene-rule-gold"/>
+          <p:cNvPr id="100092" name="!!scene-rule-gold"/>
           <p:cNvSpPr/>
           <p:nvPr/>
         </p:nvSpPr>
@@ -12846,7 +12772,7 @@
       </p:sp>
       <p:sp>
         <p:nvSpPr>
-          <p:cNvPr id="100095" name="!!scene-dot"/>
+          <p:cNvPr id="100093" name="!!scene-dot"/>
           <p:cNvSpPr/>
           <p:nvPr/>
         </p:nvSpPr>
@@ -12873,7 +12799,7 @@
       </p:sp>
       <p:sp>
         <p:nvSpPr>
-          <p:cNvPr id="100096" name="!!scene-footrule"/>
+          <p:cNvPr id="100094" name="!!scene-footrule"/>
           <p:cNvSpPr/>
           <p:nvPr/>
         </p:nvSpPr>
@@ -12900,7 +12826,7 @@
       </p:sp>
       <p:sp>
         <p:nvSpPr>
-          <p:cNvPr id="100097" name="!!#s6-eye-sec"/>
+          <p:cNvPr id="100095" name="!!#s6-eye-sec"/>
           <p:cNvSpPr txBox="1"/>
           <p:nvPr/>
         </p:nvSpPr>
@@ -12937,7 +12863,7 @@
       </p:sp>
       <p:sp>
         <p:nvSpPr>
-          <p:cNvPr id="100098" name="!!#s6-title"/>
+          <p:cNvPr id="100096" name="!!#s6-title"/>
           <p:cNvSpPr txBox="1"/>
           <p:nvPr/>
         </p:nvSpPr>
@@ -12974,7 +12900,7 @@
       </p:sp>
       <p:sp>
         <p:nvSpPr>
-          <p:cNvPr id="100099" name="!!#s6-eye-c0"/>
+          <p:cNvPr id="100097" name="!!#s6-eye-c0"/>
           <p:cNvSpPr txBox="1"/>
           <p:nvPr/>
         </p:nvSpPr>
@@ -13011,7 +12937,7 @@
       </p:sp>
       <p:sp>
         <p:nvSpPr>
-          <p:cNvPr id="100100" name="!!#s6-chead0"/>
+          <p:cNvPr id="100098" name="!!#s6-chead0"/>
           <p:cNvSpPr txBox="1"/>
           <p:nvPr/>
         </p:nvSpPr>
@@ -13052,7 +12978,7 @@
       </p:sp>
       <p:sp>
         <p:nvSpPr>
-          <p:cNvPr id="100101" name="!!#s6-cbody0"/>
+          <p:cNvPr id="100099" name="!!#s6-cbody0"/>
           <p:cNvSpPr txBox="1"/>
           <p:nvPr/>
         </p:nvSpPr>
@@ -13093,7 +13019,7 @@
       </p:sp>
       <p:sp>
         <p:nvSpPr>
-          <p:cNvPr id="100102" name="!!#s6-card1"/>
+          <p:cNvPr id="100100" name="!!#s6-card1"/>
           <p:cNvSpPr/>
           <p:nvPr/>
         </p:nvSpPr>
@@ -13124,7 +13050,7 @@
       </p:sp>
       <p:sp>
         <p:nvSpPr>
-          <p:cNvPr id="100103" name="!!#s6-eye-c1"/>
+          <p:cNvPr id="100101" name="!!#s6-eye-c1"/>
           <p:cNvSpPr txBox="1"/>
           <p:nvPr/>
         </p:nvSpPr>
@@ -13161,7 +13087,7 @@
       </p:sp>
       <p:sp>
         <p:nvSpPr>
-          <p:cNvPr id="100104" name="!!#s6-chead1"/>
+          <p:cNvPr id="100102" name="!!#s6-chead1"/>
           <p:cNvSpPr txBox="1"/>
           <p:nvPr/>
         </p:nvSpPr>
@@ -13202,7 +13128,7 @@
       </p:sp>
       <p:sp>
         <p:nvSpPr>
-          <p:cNvPr id="100105" name="!!#s6-cbody1"/>
+          <p:cNvPr id="100103" name="!!#s6-cbody1"/>
           <p:cNvSpPr txBox="1"/>
           <p:nvPr/>
         </p:nvSpPr>
@@ -13243,7 +13169,7 @@
       </p:sp>
       <p:sp>
         <p:nvSpPr>
-          <p:cNvPr id="100106" name="!!#s6-card2"/>
+          <p:cNvPr id="100104" name="!!#s6-card2"/>
           <p:cNvSpPr/>
           <p:nvPr/>
         </p:nvSpPr>
@@ -13274,7 +13200,7 @@
       </p:sp>
       <p:sp>
         <p:nvSpPr>
-          <p:cNvPr id="100107" name="!!#s6-eye-c2"/>
+          <p:cNvPr id="100105" name="!!#s6-eye-c2"/>
           <p:cNvSpPr txBox="1"/>
           <p:nvPr/>
         </p:nvSpPr>
@@ -13311,7 +13237,7 @@
       </p:sp>
       <p:sp>
         <p:nvSpPr>
-          <p:cNvPr id="100108" name="!!#s6-chead2"/>
+          <p:cNvPr id="100106" name="!!#s6-chead2"/>
           <p:cNvSpPr txBox="1"/>
           <p:nvPr/>
         </p:nvSpPr>
@@ -13352,7 +13278,7 @@
       </p:sp>
       <p:sp>
         <p:nvSpPr>
-          <p:cNvPr id="100109" name="!!#s6-cbody2"/>
+          <p:cNvPr id="100107" name="!!#s6-cbody2"/>
           <p:cNvSpPr txBox="1"/>
           <p:nvPr/>
         </p:nvSpPr>
@@ -13393,7 +13319,7 @@
       </p:sp>
       <p:sp>
         <p:nvSpPr>
-          <p:cNvPr id="100110" name="!!#s6-foot"/>
+          <p:cNvPr id="100108" name="!!#s6-foot"/>
           <p:cNvSpPr txBox="1"/>
           <p:nvPr/>
         </p:nvSpPr>
@@ -13430,7 +13356,7 @@
       </p:sp>
       <p:sp>
         <p:nvSpPr>
-          <p:cNvPr id="100111" name="!!#s6-pageno"/>
+          <p:cNvPr id="100109" name="!!#s6-pageno"/>
           <p:cNvSpPr txBox="1"/>
           <p:nvPr/>
         </p:nvSpPr>
@@ -13513,7 +13439,7 @@
                                           </p:stCondLst>
                                         </p:cTn>
                                         <p:tgtEl>
-                                          <p:spTgt spid="100098"/>
+                                          <p:spTgt spid="100096"/>
                                         </p:tgtEl>
                                         <p:attrNameLst>
                                           <p:attrName>style.visibility</p:attrName>
@@ -13527,7 +13453,7 @@
                                       <p:cBhvr>
                                         <p:cTn id="5" dur="400"/>
                                         <p:tgtEl>
-                                          <p:spTgt spid="100098"/>
+                                          <p:spTgt spid="100096"/>
                                         </p:tgtEl>
                                       </p:cBhvr>
                                     </p:animEffect>
@@ -13566,7 +13492,7 @@
                                           </p:stCondLst>
                                         </p:cTn>
                                         <p:tgtEl>
-                                          <p:spTgt spid="100100"/>
+                                          <p:spTgt spid="100098"/>
                                         </p:tgtEl>
                                         <p:attrNameLst>
                                           <p:attrName>style.visibility</p:attrName>
@@ -13580,7 +13506,7 @@
                                       <p:cBhvr>
                                         <p:cTn id="11" dur="450"/>
                                         <p:tgtEl>
-                                          <p:spTgt spid="100100"/>
+                                          <p:spTgt spid="100098"/>
                                         </p:tgtEl>
                                       </p:cBhvr>
                                     </p:animEffect>
@@ -13615,8 +13541,8 @@
       </p:par>
     </p:tnLst>
     <p:bldLst>
-      <p:bldP spid="100098" grpId="0"/>
-      <p:bldP spid="100100" grpId="1"/>
+      <p:bldP spid="100096" grpId="0"/>
+      <p:bldP spid="100098" grpId="1"/>
     </p:bldLst>
   </p:timing>
 </p:sld>
@@ -13641,7 +13567,7 @@
       <p:grpSpPr/>
       <p:sp>
         <p:nvSpPr>
-          <p:cNvPr id="100112" name="!!scene-orb-gold"/>
+          <p:cNvPr id="100110" name="!!scene-orb-gold"/>
           <p:cNvSpPr/>
           <p:nvPr/>
         </p:nvSpPr>
@@ -13678,7 +13604,7 @@
       </p:sp>
       <p:sp>
         <p:nvSpPr>
-          <p:cNvPr id="100113" name="!!scene-orb-steel"/>
+          <p:cNvPr id="100111" name="!!scene-orb-steel"/>
           <p:cNvSpPr/>
           <p:nvPr/>
         </p:nvSpPr>
@@ -13715,7 +13641,7 @@
       </p:sp>
       <p:sp>
         <p:nvSpPr>
-          <p:cNvPr id="100114" name="!!scene-wash"/>
+          <p:cNvPr id="100112" name="!!scene-wash"/>
           <p:cNvSpPr/>
           <p:nvPr/>
         </p:nvSpPr>
@@ -13746,7 +13672,7 @@
       </p:sp>
       <p:sp>
         <p:nvSpPr>
-          <p:cNvPr id="100115" name="!!scene-rule-navy"/>
+          <p:cNvPr id="100113" name="!!scene-rule-navy"/>
           <p:cNvSpPr/>
           <p:nvPr/>
         </p:nvSpPr>
@@ -13773,7 +13699,7 @@
       </p:sp>
       <p:sp>
         <p:nvSpPr>
-          <p:cNvPr id="100116" name="!!scene-rule-gold"/>
+          <p:cNvPr id="100114" name="!!scene-rule-gold"/>
           <p:cNvSpPr/>
           <p:nvPr/>
         </p:nvSpPr>
@@ -13800,7 +13726,7 @@
       </p:sp>
       <p:sp>
         <p:nvSpPr>
-          <p:cNvPr id="100117" name="!!scene-dot"/>
+          <p:cNvPr id="100115" name="!!scene-dot"/>
           <p:cNvSpPr/>
           <p:nvPr/>
         </p:nvSpPr>
@@ -13827,7 +13753,7 @@
       </p:sp>
       <p:sp>
         <p:nvSpPr>
-          <p:cNvPr id="100118" name="!!#s7-topbar"/>
+          <p:cNvPr id="100116" name="!!#s7-topbar"/>
           <p:cNvSpPr txBox="1"/>
           <p:nvPr/>
         </p:nvSpPr>
@@ -13864,7 +13790,7 @@
       </p:sp>
       <p:sp>
         <p:nvSpPr>
-          <p:cNvPr id="100119" name="!!#s7-num"/>
+          <p:cNvPr id="100117" name="!!#s7-num"/>
           <p:cNvSpPr txBox="1"/>
           <p:nvPr/>
         </p:nvSpPr>
@@ -13901,7 +13827,7 @@
       </p:sp>
       <p:sp>
         <p:nvSpPr>
-          <p:cNvPr id="100120" name="!!#s7-title"/>
+          <p:cNvPr id="100118" name="!!#s7-title"/>
           <p:cNvSpPr txBox="1"/>
           <p:nvPr/>
         </p:nvSpPr>
@@ -13938,7 +13864,7 @@
       </p:sp>
       <p:sp>
         <p:nvSpPr>
-          <p:cNvPr id="100121" name="!!#s7-strap"/>
+          <p:cNvPr id="100119" name="!!#s7-strap"/>
           <p:cNvSpPr txBox="1"/>
           <p:nvPr/>
         </p:nvSpPr>
@@ -14025,7 +13951,7 @@
                                           </p:stCondLst>
                                         </p:cTn>
                                         <p:tgtEl>
-                                          <p:spTgt spid="100120"/>
+                                          <p:spTgt spid="100118"/>
                                         </p:tgtEl>
                                         <p:attrNameLst>
                                           <p:attrName>style.visibility</p:attrName>
@@ -14039,7 +13965,7 @@
                                       <p:cBhvr>
                                         <p:cTn id="5" dur="400"/>
                                         <p:tgtEl>
-                                          <p:spTgt spid="100120"/>
+                                          <p:spTgt spid="100118"/>
                                         </p:tgtEl>
                                       </p:cBhvr>
                                     </p:animEffect>
@@ -14078,7 +14004,7 @@
                                           </p:stCondLst>
                                         </p:cTn>
                                         <p:tgtEl>
-                                          <p:spTgt spid="100119"/>
+                                          <p:spTgt spid="100117"/>
                                         </p:tgtEl>
                                         <p:attrNameLst>
                                           <p:attrName>style.visibility</p:attrName>
@@ -14092,7 +14018,7 @@
                                       <p:cBhvr>
                                         <p:cTn id="11" dur="500"/>
                                         <p:tgtEl>
-                                          <p:spTgt spid="100119"/>
+                                          <p:spTgt spid="100117"/>
                                         </p:tgtEl>
                                       </p:cBhvr>
                                     </p:animEffect>
@@ -14127,8 +14053,8 @@
       </p:par>
     </p:tnLst>
     <p:bldLst>
-      <p:bldP spid="100120" grpId="0"/>
-      <p:bldP spid="100119" grpId="1"/>
+      <p:bldP spid="100118" grpId="0"/>
+      <p:bldP spid="100117" grpId="1"/>
     </p:bldLst>
   </p:timing>
 </p:sld>
@@ -14153,7 +14079,7 @@
       <p:grpSpPr/>
       <p:sp>
         <p:nvSpPr>
-          <p:cNvPr id="100122" name="!!scene-orb-gold"/>
+          <p:cNvPr id="100120" name="!!scene-orb-gold"/>
           <p:cNvSpPr/>
           <p:nvPr/>
         </p:nvSpPr>
@@ -14190,7 +14116,7 @@
       </p:sp>
       <p:sp>
         <p:nvSpPr>
-          <p:cNvPr id="100123" name="!!scene-orb-steel"/>
+          <p:cNvPr id="100121" name="!!scene-orb-steel"/>
           <p:cNvSpPr/>
           <p:nvPr/>
         </p:nvSpPr>
@@ -14227,7 +14153,7 @@
       </p:sp>
       <p:sp>
         <p:nvSpPr>
-          <p:cNvPr id="100124" name="!!scene-wash"/>
+          <p:cNvPr id="100122" name="!!scene-wash"/>
           <p:cNvSpPr/>
           <p:nvPr/>
         </p:nvSpPr>
@@ -14258,7 +14184,7 @@
       </p:sp>
       <p:sp>
         <p:nvSpPr>
-          <p:cNvPr id="100125" name="!!scene-rule-navy"/>
+          <p:cNvPr id="100123" name="!!scene-rule-navy"/>
           <p:cNvSpPr/>
           <p:nvPr/>
         </p:nvSpPr>
@@ -14285,7 +14211,7 @@
       </p:sp>
       <p:sp>
         <p:nvSpPr>
-          <p:cNvPr id="100126" name="!!scene-rule-gold"/>
+          <p:cNvPr id="100124" name="!!scene-rule-gold"/>
           <p:cNvSpPr/>
           <p:nvPr/>
         </p:nvSpPr>
@@ -14312,7 +14238,7 @@
       </p:sp>
       <p:sp>
         <p:nvSpPr>
-          <p:cNvPr id="100127" name="!!scene-dot"/>
+          <p:cNvPr id="100125" name="!!scene-dot"/>
           <p:cNvSpPr/>
           <p:nvPr/>
         </p:nvSpPr>
@@ -14339,7 +14265,7 @@
       </p:sp>
       <p:sp>
         <p:nvSpPr>
-          <p:cNvPr id="100128" name="!!scene-footrule"/>
+          <p:cNvPr id="100126" name="!!scene-footrule"/>
           <p:cNvSpPr/>
           <p:nvPr/>
         </p:nvSpPr>
@@ -14366,7 +14292,7 @@
       </p:sp>
       <p:sp>
         <p:nvSpPr>
-          <p:cNvPr id="100129" name="!!#s8-eye-sec"/>
+          <p:cNvPr id="100127" name="!!#s8-eye-sec"/>
           <p:cNvSpPr txBox="1"/>
           <p:nvPr/>
         </p:nvSpPr>
@@ -14403,7 +14329,7 @@
       </p:sp>
       <p:sp>
         <p:nvSpPr>
-          <p:cNvPr id="100130" name="!!#s8-title"/>
+          <p:cNvPr id="100128" name="!!#s8-title"/>
           <p:cNvSpPr txBox="1"/>
           <p:nvPr/>
         </p:nvSpPr>
@@ -14440,7 +14366,7 @@
       </p:sp>
       <p:sp>
         <p:nvSpPr>
-          <p:cNvPr id="100131" name="!!#s8-chip0"/>
+          <p:cNvPr id="100129" name="!!#s8-chip0"/>
           <p:cNvSpPr/>
           <p:nvPr/>
         </p:nvSpPr>
@@ -14479,7 +14405,7 @@
       </p:sp>
       <p:sp>
         <p:nvSpPr>
-          <p:cNvPr id="100132" name="!!#s8-shead0"/>
+          <p:cNvPr id="100130" name="!!#s8-shead0"/>
           <p:cNvSpPr txBox="1"/>
           <p:nvPr/>
         </p:nvSpPr>
@@ -14516,7 +14442,7 @@
       </p:sp>
       <p:sp>
         <p:nvSpPr>
-          <p:cNvPr id="100133" name="!!#s8-sbody0"/>
+          <p:cNvPr id="100131" name="!!#s8-sbody0"/>
           <p:cNvSpPr txBox="1"/>
           <p:nvPr/>
         </p:nvSpPr>
@@ -14557,7 +14483,7 @@
       </p:sp>
       <p:sp>
         <p:nvSpPr>
-          <p:cNvPr id="100134" name="!!#s8-row1"/>
+          <p:cNvPr id="100132" name="!!#s8-row1"/>
           <p:cNvSpPr/>
           <p:nvPr/>
         </p:nvSpPr>
@@ -14588,7 +14514,7 @@
       </p:sp>
       <p:sp>
         <p:nvSpPr>
-          <p:cNvPr id="100135" name="!!#s8-chip1"/>
+          <p:cNvPr id="100133" name="!!#s8-chip1"/>
           <p:cNvSpPr/>
           <p:nvPr/>
         </p:nvSpPr>
@@ -14627,7 +14553,7 @@
       </p:sp>
       <p:sp>
         <p:nvSpPr>
-          <p:cNvPr id="100136" name="!!#s8-shead1"/>
+          <p:cNvPr id="100134" name="!!#s8-shead1"/>
           <p:cNvSpPr txBox="1"/>
           <p:nvPr/>
         </p:nvSpPr>
@@ -14664,7 +14590,7 @@
       </p:sp>
       <p:sp>
         <p:nvSpPr>
-          <p:cNvPr id="100137" name="!!#s8-sbody1"/>
+          <p:cNvPr id="100135" name="!!#s8-sbody1"/>
           <p:cNvSpPr txBox="1"/>
           <p:nvPr/>
         </p:nvSpPr>
@@ -14705,7 +14631,7 @@
       </p:sp>
       <p:sp>
         <p:nvSpPr>
-          <p:cNvPr id="100138" name="!!#s8-row2"/>
+          <p:cNvPr id="100136" name="!!#s8-row2"/>
           <p:cNvSpPr/>
           <p:nvPr/>
         </p:nvSpPr>
@@ -14736,7 +14662,7 @@
       </p:sp>
       <p:sp>
         <p:nvSpPr>
-          <p:cNvPr id="100139" name="!!#s8-chip2"/>
+          <p:cNvPr id="100137" name="!!#s8-chip2"/>
           <p:cNvSpPr/>
           <p:nvPr/>
         </p:nvSpPr>
@@ -14775,7 +14701,7 @@
       </p:sp>
       <p:sp>
         <p:nvSpPr>
-          <p:cNvPr id="100140" name="!!#s8-shead2"/>
+          <p:cNvPr id="100138" name="!!#s8-shead2"/>
           <p:cNvSpPr txBox="1"/>
           <p:nvPr/>
         </p:nvSpPr>
@@ -14812,7 +14738,7 @@
       </p:sp>
       <p:sp>
         <p:nvSpPr>
-          <p:cNvPr id="100141" name="!!#s8-sbody2"/>
+          <p:cNvPr id="100139" name="!!#s8-sbody2"/>
           <p:cNvSpPr txBox="1"/>
           <p:nvPr/>
         </p:nvSpPr>
@@ -14853,7 +14779,7 @@
       </p:sp>
       <p:sp>
         <p:nvSpPr>
-          <p:cNvPr id="100142" name="!!#s8-row3"/>
+          <p:cNvPr id="100140" name="!!#s8-row3"/>
           <p:cNvSpPr/>
           <p:nvPr/>
         </p:nvSpPr>
@@ -14884,7 +14810,7 @@
       </p:sp>
       <p:sp>
         <p:nvSpPr>
-          <p:cNvPr id="100143" name="!!#s8-chip3"/>
+          <p:cNvPr id="100141" name="!!#s8-chip3"/>
           <p:cNvSpPr/>
           <p:nvPr/>
         </p:nvSpPr>
@@ -14923,7 +14849,7 @@
       </p:sp>
       <p:sp>
         <p:nvSpPr>
-          <p:cNvPr id="100144" name="!!#s8-shead3"/>
+          <p:cNvPr id="100142" name="!!#s8-shead3"/>
           <p:cNvSpPr txBox="1"/>
           <p:nvPr/>
         </p:nvSpPr>
@@ -14960,7 +14886,7 @@
       </p:sp>
       <p:sp>
         <p:nvSpPr>
-          <p:cNvPr id="100145" name="!!#s8-sbody3"/>
+          <p:cNvPr id="100143" name="!!#s8-sbody3"/>
           <p:cNvSpPr txBox="1"/>
           <p:nvPr/>
         </p:nvSpPr>
@@ -15001,10 +14927,10 @@
       </p:sp>
       <p:cxnSp>
         <p:nvCxnSpPr>
-          <p:cNvPr id="100146" name="Connector 1"/>
+          <p:cNvPr id="100144" name="Connector 1"/>
           <p:cNvCxnSpPr>
-            <a:stCxn xmlns:a="http://schemas.openxmlformats.org/drawingml/2006/main" id="100131" idx="0"/>
-            <a:endCxn xmlns:a="http://schemas.openxmlformats.org/drawingml/2006/main" id="100135" idx="0"/>
+            <a:stCxn xmlns:a="http://schemas.openxmlformats.org/drawingml/2006/main" id="100129" idx="0"/>
+            <a:endCxn xmlns:a="http://schemas.openxmlformats.org/drawingml/2006/main" id="100133" idx="0"/>
           </p:cNvCxnSpPr>
           <p:nvPr/>
         </p:nvCxnSpPr>
@@ -15026,10 +14952,10 @@
       </p:cxnSp>
       <p:cxnSp>
         <p:nvCxnSpPr>
-          <p:cNvPr id="100147" name="Connector 2"/>
+          <p:cNvPr id="100145" name="Connector 2"/>
           <p:cNvCxnSpPr>
-            <a:stCxn xmlns:a="http://schemas.openxmlformats.org/drawingml/2006/main" id="100135" idx="0"/>
-            <a:endCxn xmlns:a="http://schemas.openxmlformats.org/drawingml/2006/main" id="100139" idx="0"/>
+            <a:stCxn xmlns:a="http://schemas.openxmlformats.org/drawingml/2006/main" id="100133" idx="0"/>
+            <a:endCxn xmlns:a="http://schemas.openxmlformats.org/drawingml/2006/main" id="100137" idx="0"/>
           </p:cNvCxnSpPr>
           <p:nvPr/>
         </p:nvCxnSpPr>
@@ -15051,10 +14977,10 @@
       </p:cxnSp>
       <p:cxnSp>
         <p:nvCxnSpPr>
-          <p:cNvPr id="100148" name="Connector 3"/>
+          <p:cNvPr id="100146" name="Connector 3"/>
           <p:cNvCxnSpPr>
-            <a:stCxn xmlns:a="http://schemas.openxmlformats.org/drawingml/2006/main" id="100139" idx="0"/>
-            <a:endCxn xmlns:a="http://schemas.openxmlformats.org/drawingml/2006/main" id="100143" idx="0"/>
+            <a:stCxn xmlns:a="http://schemas.openxmlformats.org/drawingml/2006/main" id="100137" idx="0"/>
+            <a:endCxn xmlns:a="http://schemas.openxmlformats.org/drawingml/2006/main" id="100141" idx="0"/>
           </p:cNvCxnSpPr>
           <p:nvPr/>
         </p:nvCxnSpPr>
@@ -15076,7 +15002,7 @@
       </p:cxnSp>
       <p:sp>
         <p:nvSpPr>
-          <p:cNvPr id="100149" name="!!#s8-foot"/>
+          <p:cNvPr id="100147" name="!!#s8-foot"/>
           <p:cNvSpPr txBox="1"/>
           <p:nvPr/>
         </p:nvSpPr>
@@ -15113,7 +15039,7 @@
       </p:sp>
       <p:sp>
         <p:nvSpPr>
-          <p:cNvPr id="100150" name="!!#s8-pageno"/>
+          <p:cNvPr id="100148" name="!!#s8-pageno"/>
           <p:cNvSpPr txBox="1"/>
           <p:nvPr/>
         </p:nvSpPr>
@@ -15196,7 +15122,7 @@
                                           </p:stCondLst>
                                         </p:cTn>
                                         <p:tgtEl>
-                                          <p:spTgt spid="100130"/>
+                                          <p:spTgt spid="100128"/>
                                         </p:tgtEl>
                                         <p:attrNameLst>
                                           <p:attrName>style.visibility</p:attrName>
@@ -15210,7 +15136,7 @@
                                       <p:cBhvr>
                                         <p:cTn id="5" dur="400"/>
                                         <p:tgtEl>
-                                          <p:spTgt spid="100130"/>
+                                          <p:spTgt spid="100128"/>
                                         </p:tgtEl>
                                       </p:cBhvr>
                                     </p:animEffect>
@@ -15249,7 +15175,7 @@
                                           </p:stCondLst>
                                         </p:cTn>
                                         <p:tgtEl>
-                                          <p:spTgt spid="100132"/>
+                                          <p:spTgt spid="100130"/>
                                         </p:tgtEl>
                                         <p:attrNameLst>
                                           <p:attrName>style.visibility</p:attrName>
@@ -15263,7 +15189,7 @@
                                       <p:cBhvr>
                                         <p:cTn id="11" dur="450"/>
                                         <p:tgtEl>
-                                          <p:spTgt spid="100132"/>
+                                          <p:spTgt spid="100130"/>
                                         </p:tgtEl>
                                       </p:cBhvr>
                                     </p:animEffect>
@@ -15298,8 +15224,8 @@
       </p:par>
     </p:tnLst>
     <p:bldLst>
-      <p:bldP spid="100130" grpId="0"/>
-      <p:bldP spid="100132" grpId="1"/>
+      <p:bldP spid="100128" grpId="0"/>
+      <p:bldP spid="100130" grpId="1"/>
     </p:bldLst>
   </p:timing>
 </p:sld>
@@ -15324,7 +15250,7 @@
       <p:grpSpPr/>
       <p:sp>
         <p:nvSpPr>
-          <p:cNvPr id="100151" name="!!scene-orb-gold"/>
+          <p:cNvPr id="100149" name="!!scene-orb-gold"/>
           <p:cNvSpPr/>
           <p:nvPr/>
         </p:nvSpPr>
@@ -15361,7 +15287,7 @@
       </p:sp>
       <p:sp>
         <p:nvSpPr>
-          <p:cNvPr id="100152" name="!!scene-orb-steel"/>
+          <p:cNvPr id="100150" name="!!scene-orb-steel"/>
           <p:cNvSpPr/>
           <p:nvPr/>
         </p:nvSpPr>
@@ -15398,7 +15324,7 @@
       </p:sp>
       <p:sp>
         <p:nvSpPr>
-          <p:cNvPr id="100153" name="!!scene-wash"/>
+          <p:cNvPr id="100151" name="!!scene-wash"/>
           <p:cNvSpPr/>
           <p:nvPr/>
         </p:nvSpPr>
@@ -15429,7 +15355,7 @@
       </p:sp>
       <p:sp>
         <p:nvSpPr>
-          <p:cNvPr id="100154" name="!!scene-rule-navy"/>
+          <p:cNvPr id="100152" name="!!scene-rule-navy"/>
           <p:cNvSpPr/>
           <p:nvPr/>
         </p:nvSpPr>
@@ -15456,7 +15382,7 @@
       </p:sp>
       <p:sp>
         <p:nvSpPr>
-          <p:cNvPr id="100155" name="!!scene-rule-gold"/>
+          <p:cNvPr id="100153" name="!!scene-rule-gold"/>
           <p:cNvSpPr/>
           <p:nvPr/>
         </p:nvSpPr>
@@ -15483,7 +15409,7 @@
       </p:sp>
       <p:sp>
         <p:nvSpPr>
-          <p:cNvPr id="100156" name="!!scene-dot"/>
+          <p:cNvPr id="100154" name="!!scene-dot"/>
           <p:cNvSpPr/>
           <p:nvPr/>
         </p:nvSpPr>
@@ -15510,7 +15436,7 @@
       </p:sp>
       <p:sp>
         <p:nvSpPr>
-          <p:cNvPr id="100157" name="!!scene-footrule"/>
+          <p:cNvPr id="100155" name="!!scene-footrule"/>
           <p:cNvSpPr/>
           <p:nvPr/>
         </p:nvSpPr>
@@ -15537,7 +15463,7 @@
       </p:sp>
       <p:sp>
         <p:nvSpPr>
-          <p:cNvPr id="100158" name="!!#s9-eye-sec"/>
+          <p:cNvPr id="100156" name="!!#s9-eye-sec"/>
           <p:cNvSpPr txBox="1"/>
           <p:nvPr/>
         </p:nvSpPr>
@@ -15574,7 +15500,7 @@
       </p:sp>
       <p:sp>
         <p:nvSpPr>
-          <p:cNvPr id="100159" name="!!#s9-title"/>
+          <p:cNvPr id="100157" name="!!#s9-title"/>
           <p:cNvSpPr txBox="1"/>
           <p:nvPr/>
         </p:nvSpPr>
@@ -15611,7 +15537,7 @@
       </p:sp>
       <p:sp>
         <p:nvSpPr>
-          <p:cNvPr id="100160" name="!!#s9-eye-diff"/>
+          <p:cNvPr id="100158" name="!!#s9-eye-diff"/>
           <p:cNvSpPr txBox="1"/>
           <p:nvPr/>
         </p:nvSpPr>
@@ -15648,7 +15574,7 @@
       </p:sp>
       <p:sp>
         <p:nvSpPr>
-          <p:cNvPr id="100161" name="!!#s9-figure"/>
+          <p:cNvPr id="100159" name="!!#s9-figure"/>
           <p:cNvSpPr txBox="1"/>
           <p:nvPr/>
         </p:nvSpPr>
@@ -15685,7 +15611,7 @@
       </p:sp>
       <p:sp>
         <p:nvSpPr>
-          <p:cNvPr id="100162" name="!!#s9-figsub"/>
+          <p:cNvPr id="100160" name="!!#s9-figsub"/>
           <p:cNvSpPr txBox="1"/>
           <p:nvPr/>
         </p:nvSpPr>
@@ -15726,7 +15652,7 @@
       </p:sp>
       <p:sp>
         <p:nvSpPr>
-          <p:cNvPr id="100163" name="!!#s9-lead"/>
+          <p:cNvPr id="100161" name="!!#s9-lead"/>
           <p:cNvSpPr txBox="1"/>
           <p:nvPr/>
         </p:nvSpPr>
@@ -15767,7 +15693,7 @@
       </p:sp>
       <p:sp>
         <p:nvSpPr>
-          <p:cNvPr id="100164" name="!!#s9-dash0"/>
+          <p:cNvPr id="100162" name="!!#s9-dash0"/>
           <p:cNvSpPr/>
           <p:nvPr/>
         </p:nvSpPr>
@@ -15794,7 +15720,7 @@
       </p:sp>
       <p:sp>
         <p:nvSpPr>
-          <p:cNvPr id="100165" name="!!#s9-chip0"/>
+          <p:cNvPr id="100163" name="!!#s9-chip0"/>
           <p:cNvSpPr txBox="1"/>
           <p:nvPr/>
         </p:nvSpPr>
@@ -15835,7 +15761,7 @@
       </p:sp>
       <p:sp>
         <p:nvSpPr>
-          <p:cNvPr id="100166" name="!!#s9-dash1"/>
+          <p:cNvPr id="100164" name="!!#s9-dash1"/>
           <p:cNvSpPr/>
           <p:nvPr/>
         </p:nvSpPr>
@@ -15862,7 +15788,7 @@
       </p:sp>
       <p:sp>
         <p:nvSpPr>
-          <p:cNvPr id="100167" name="!!#s9-chip1"/>
+          <p:cNvPr id="100165" name="!!#s9-chip1"/>
           <p:cNvSpPr txBox="1"/>
           <p:nvPr/>
         </p:nvSpPr>
@@ -15903,7 +15829,7 @@
       </p:sp>
       <p:sp>
         <p:nvSpPr>
-          <p:cNvPr id="100168" name="!!#s9-dash2"/>
+          <p:cNvPr id="100166" name="!!#s9-dash2"/>
           <p:cNvSpPr/>
           <p:nvPr/>
         </p:nvSpPr>
@@ -15930,7 +15856,7 @@
       </p:sp>
       <p:sp>
         <p:nvSpPr>
-          <p:cNvPr id="100169" name="!!#s9-chip2"/>
+          <p:cNvPr id="100167" name="!!#s9-chip2"/>
           <p:cNvSpPr txBox="1"/>
           <p:nvPr/>
         </p:nvSpPr>
@@ -15971,7 +15897,7 @@
       </p:sp>
       <p:sp>
         <p:nvSpPr>
-          <p:cNvPr id="100170" name="!!#s9-foot"/>
+          <p:cNvPr id="100168" name="!!#s9-foot"/>
           <p:cNvSpPr txBox="1"/>
           <p:nvPr/>
         </p:nvSpPr>
@@ -16008,7 +15934,7 @@
       </p:sp>
       <p:sp>
         <p:nvSpPr>
-          <p:cNvPr id="100171" name="!!#s9-pageno"/>
+          <p:cNvPr id="100169" name="!!#s9-pageno"/>
           <p:cNvSpPr txBox="1"/>
           <p:nvPr/>
         </p:nvSpPr>
@@ -16091,7 +16017,7 @@
                                           </p:stCondLst>
                                         </p:cTn>
                                         <p:tgtEl>
-                                          <p:spTgt spid="100159"/>
+                                          <p:spTgt spid="100157"/>
                                         </p:tgtEl>
                                         <p:attrNameLst>
                                           <p:attrName>style.visibility</p:attrName>
@@ -16105,7 +16031,7 @@
                                       <p:cBhvr>
                                         <p:cTn id="5" dur="400"/>
                                         <p:tgtEl>
-                                          <p:spTgt spid="100159"/>
+                                          <p:spTgt spid="100157"/>
                                         </p:tgtEl>
                                       </p:cBhvr>
                                     </p:animEffect>
@@ -16144,7 +16070,7 @@
                                           </p:stCondLst>
                                         </p:cTn>
                                         <p:tgtEl>
-                                          <p:spTgt spid="100161"/>
+                                          <p:spTgt spid="100159"/>
                                         </p:tgtEl>
                                         <p:attrNameLst>
                                           <p:attrName>style.visibility</p:attrName>
@@ -16158,7 +16084,7 @@
                                       <p:cBhvr>
                                         <p:cTn id="11" dur="550" fill="hold"/>
                                         <p:tgtEl>
-                                          <p:spTgt spid="100161"/>
+                                          <p:spTgt spid="100159"/>
                                         </p:tgtEl>
                                       </p:cBhvr>
                                       <p:from x="0" y="0"/>
@@ -16195,8 +16121,8 @@
       </p:par>
     </p:tnLst>
     <p:bldLst>
-      <p:bldP spid="100159" grpId="0"/>
-      <p:bldP spid="100161" grpId="1"/>
+      <p:bldP spid="100157" grpId="0"/>
+      <p:bldP spid="100159" grpId="1"/>
     </p:bldLst>
   </p:timing>
 </p:sld>

</xml_diff>

<commit_message>
Add Singapore number to the closing contact block
+65 84083838 joins the two India numbers on slide 16. The phone column
goes from two lines to three, so the step cards give back 0.30cm and
the contact block lifts to stay clear of the footrule.

PDF regenerated.

Gates: validate clean, view issues 0.

Co-Authored-By: Claude Opus 5 <noreply@anthropic.com>
Claude-Session: https://claude.ai/code/session_019z6znKoXgkS3KRD4bBqrbf
</commit_message>
<xml_diff>
--- a/singapore-deck/taxwise-singapore.pptx
+++ b/singapore-deck/taxwise-singapore.pptx
@@ -5,25 +5,25 @@
     <p:sldMasterId xmlns:r="http://schemas.openxmlformats.org/officeDocument/2006/relationships" id="2147483648" r:id="rId1"/>
   </p:sldMasterIdLst>
   <p:notesMasterIdLst>
-    <p:notesMasterId r:id="R56a9006fb9e248d2"/>
+    <p:notesMasterId r:id="R0d9098014392446c"/>
   </p:notesMasterIdLst>
   <p:sldIdLst>
-    <p:sldId id="256" r:id="Rd58cf227236a4ef1"/>
-    <p:sldId id="257" r:id="R0f5aed4fbbe54282"/>
-    <p:sldId id="258" r:id="Rfc01610f42814962"/>
-    <p:sldId id="259" r:id="Rab75c4c6431f481b"/>
-    <p:sldId id="260" r:id="R9b4a28c9957d4432"/>
-    <p:sldId id="261" r:id="R4b80013543894482"/>
-    <p:sldId id="262" r:id="Rc1b5bb1a8f1346b1"/>
-    <p:sldId id="263" r:id="R22310309403b456c"/>
-    <p:sldId id="264" r:id="R0e78697b83f04fa8"/>
-    <p:sldId id="265" r:id="R76f0114ce81b4a6d"/>
-    <p:sldId id="266" r:id="R57174691eea94996"/>
-    <p:sldId id="267" r:id="R682390e7d9fe4bfb"/>
-    <p:sldId id="268" r:id="R9af8a8f90ac743b8"/>
-    <p:sldId id="269" r:id="R779e40e24a8649ba"/>
-    <p:sldId id="270" r:id="R5b07fb05d7cb4e81"/>
-    <p:sldId id="271" r:id="Re1c6dc30e08c4a3a"/>
+    <p:sldId id="256" r:id="Rc82c1e4586844cbe"/>
+    <p:sldId id="257" r:id="R1ecd0c2d38ea4ff7"/>
+    <p:sldId id="258" r:id="R0b67fdfb65dd4938"/>
+    <p:sldId id="259" r:id="R2a3412ee89ae4bad"/>
+    <p:sldId id="260" r:id="R858e3b5818bd42a0"/>
+    <p:sldId id="261" r:id="R5c08c2423a814be4"/>
+    <p:sldId id="262" r:id="R2c56e49ab70f4df7"/>
+    <p:sldId id="263" r:id="Rb57e1375ba794110"/>
+    <p:sldId id="264" r:id="R02a332757ccd493d"/>
+    <p:sldId id="265" r:id="Rfdbf7b436a034ed8"/>
+    <p:sldId id="266" r:id="Rc29a35b79f2f4bac"/>
+    <p:sldId id="267" r:id="R5095b204a9f24a4c"/>
+    <p:sldId id="268" r:id="R48241aefa5764a73"/>
+    <p:sldId id="269" r:id="Rcc96421997d14ac8"/>
+    <p:sldId id="270" r:id="R89f28dc322be40da"/>
+    <p:sldId id="271" r:id="R4debc71e9eee4129"/>
   </p:sldIdLst>
   <p:sldSz cx="12192000" cy="6858000"/>
   <p:notesSz cx="6858000" cy="9144000"/>
@@ -1771,7 +1771,7 @@
           <p:nvPr/>
         </p:nvPicPr>
         <p:blipFill>
-          <a:blip xmlns:r="http://schemas.openxmlformats.org/officeDocument/2006/relationships" xmlns:a="http://schemas.openxmlformats.org/drawingml/2006/main" r:embed="R2365bdba2062428b"/>
+          <a:blip xmlns:r="http://schemas.openxmlformats.org/officeDocument/2006/relationships" xmlns:a="http://schemas.openxmlformats.org/drawingml/2006/main" r:embed="R3359aa6afd6044a6"/>
           <a:stretch xmlns:a="http://schemas.openxmlformats.org/drawingml/2006/main">
             <a:fillRect/>
           </a:stretch>
@@ -8044,7 +8044,7 @@
         <p:spPr>
           <a:xfrm xmlns:a="http://schemas.openxmlformats.org/drawingml/2006/main">
             <a:off x="684000" y="2448000"/>
-            <a:ext cx="3391200" cy="2232000"/>
+            <a:ext cx="3391200" cy="2124000"/>
           </a:xfrm>
           <a:prstGeom xmlns:a="http://schemas.openxmlformats.org/drawingml/2006/main" prst="roundRect">
             <a:avLst>
@@ -8074,8 +8074,8 @@
         </p:nvSpPr>
         <p:spPr>
           <a:xfrm xmlns:a="http://schemas.openxmlformats.org/drawingml/2006/main">
-            <a:off x="11509200" y="5148000"/>
-            <a:ext cx="18000" cy="720000"/>
+            <a:off x="11509200" y="5004000"/>
+            <a:ext cx="18000" cy="864000"/>
           </a:xfrm>
           <a:prstGeom xmlns:a="http://schemas.openxmlformats.org/drawingml/2006/main" prst="rect">
             <a:avLst/>
@@ -8376,7 +8376,7 @@
         <p:spPr>
           <a:xfrm xmlns:a="http://schemas.openxmlformats.org/drawingml/2006/main">
             <a:off x="4399200" y="2448000"/>
-            <a:ext cx="3391200" cy="2232000"/>
+            <a:ext cx="3391200" cy="2124000"/>
           </a:xfrm>
           <a:prstGeom xmlns:a="http://schemas.openxmlformats.org/drawingml/2006/main" prst="roundRect">
             <a:avLst>
@@ -8526,7 +8526,7 @@
         <p:spPr>
           <a:xfrm xmlns:a="http://schemas.openxmlformats.org/drawingml/2006/main">
             <a:off x="8118000" y="2448000"/>
-            <a:ext cx="3391200" cy="2232000"/>
+            <a:ext cx="3391200" cy="2124000"/>
           </a:xfrm>
           <a:prstGeom xmlns:a="http://schemas.openxmlformats.org/drawingml/2006/main" prst="roundRect">
             <a:avLst>
@@ -8675,7 +8675,7 @@
         </p:nvSpPr>
         <p:spPr>
           <a:xfrm xmlns:a="http://schemas.openxmlformats.org/drawingml/2006/main">
-            <a:off x="684000" y="4932000"/>
+            <a:off x="684000" y="4770000"/>
             <a:ext cx="10825200" cy="18000"/>
           </a:xfrm>
           <a:prstGeom xmlns:a="http://schemas.openxmlformats.org/drawingml/2006/main" prst="rect">
@@ -8702,7 +8702,7 @@
         </p:nvSpPr>
         <p:spPr>
           <a:xfrm xmlns:a="http://schemas.openxmlformats.org/drawingml/2006/main">
-            <a:off x="684000" y="5094000"/>
+            <a:off x="684000" y="4932000"/>
             <a:ext cx="3391200" cy="252000"/>
           </a:xfrm>
           <a:prstGeom xmlns:a="http://schemas.openxmlformats.org/drawingml/2006/main" prst="rect">
@@ -8739,8 +8739,8 @@
         </p:nvSpPr>
         <p:spPr>
           <a:xfrm xmlns:a="http://schemas.openxmlformats.org/drawingml/2006/main">
-            <a:off x="684000" y="5364000"/>
-            <a:ext cx="3391200" cy="576000"/>
+            <a:off x="684000" y="5220000"/>
+            <a:ext cx="3391200" cy="810000"/>
           </a:xfrm>
           <a:prstGeom xmlns:a="http://schemas.openxmlformats.org/drawingml/2006/main" prst="rect">
             <a:avLst/>
@@ -8780,7 +8780,7 @@
         </p:nvSpPr>
         <p:spPr>
           <a:xfrm xmlns:a="http://schemas.openxmlformats.org/drawingml/2006/main">
-            <a:off x="4399200" y="5094000"/>
+            <a:off x="4399200" y="4932000"/>
             <a:ext cx="3391200" cy="252000"/>
           </a:xfrm>
           <a:prstGeom xmlns:a="http://schemas.openxmlformats.org/drawingml/2006/main" prst="rect">
@@ -8817,8 +8817,8 @@
         </p:nvSpPr>
         <p:spPr>
           <a:xfrm xmlns:a="http://schemas.openxmlformats.org/drawingml/2006/main">
-            <a:off x="4399200" y="5364000"/>
-            <a:ext cx="3391200" cy="576000"/>
+            <a:off x="4399200" y="5220000"/>
+            <a:ext cx="3391200" cy="810000"/>
           </a:xfrm>
           <a:prstGeom xmlns:a="http://schemas.openxmlformats.org/drawingml/2006/main" prst="rect">
             <a:avLst/>
@@ -8865,40 +8865,57 @@
               <a:t>+91 9740540239</a:t>
             </a:r>
           </a:p>
-        </p:txBody>
-      </p:sp>
-      <p:sp>
-        <p:nvSpPr>
-          <p:cNvPr id="100334" name="!!#s16-eye-ct2"/>
-          <p:cNvSpPr txBox="1"/>
-          <p:nvPr/>
-        </p:nvSpPr>
-        <p:spPr>
-          <a:xfrm xmlns:a="http://schemas.openxmlformats.org/drawingml/2006/main">
-            <a:off x="8118000" y="5094000"/>
-            <a:ext cx="3391200" cy="252000"/>
-          </a:xfrm>
-          <a:prstGeom xmlns:a="http://schemas.openxmlformats.org/drawingml/2006/main" prst="rect">
-            <a:avLst/>
-          </a:prstGeom>
-          <a:noFill xmlns:a="http://schemas.openxmlformats.org/drawingml/2006/main"/>
-          <a:ln xmlns:a="http://schemas.openxmlformats.org/drawingml/2006/main">
-            <a:noFill/>
-          </a:ln>
-        </p:spPr>
-        <p:txBody>
-          <a:bodyPr xmlns:a="http://schemas.openxmlformats.org/drawingml/2006/main" lIns="0" tIns="0" rIns="0" bIns="0" anchor="ctr"/>
-          <a:lstStyle xmlns:a="http://schemas.openxmlformats.org/drawingml/2006/main"/>
-          <a:p xmlns:a="http://schemas.openxmlformats.org/drawingml/2006/main">
-            <a:pPr algn="l"/>
-            <a:r>
-              <a:rPr lang="en-US" sz="1050" b="1" spc="220">
-                <a:solidFill>
-                  <a:srgbClr val="C9A84C"/>
+          <a:p xmlns:a="http://schemas.openxmlformats.org/drawingml/2006/main">
+            <a:pPr algn="l">
+              <a:lnSpc>
+                <a:spcPct val="115000"/>
+              </a:lnSpc>
+            </a:pPr>
+            <a:r>
+              <a:rPr lang="en-US" sz="1500">
+                <a:solidFill>
+                  <a:srgbClr val="8A9BBF"/>
                 </a:solidFill>
                 <a:latin typeface="Arial"/>
                 <a:ea typeface="Arial"/>
               </a:rPr>
+              <a:t>+65 84083838</a:t>
+            </a:r>
+          </a:p>
+        </p:txBody>
+      </p:sp>
+      <p:sp>
+        <p:nvSpPr>
+          <p:cNvPr id="100334" name="!!#s16-eye-ct2"/>
+          <p:cNvSpPr txBox="1"/>
+          <p:nvPr/>
+        </p:nvSpPr>
+        <p:spPr>
+          <a:xfrm xmlns:a="http://schemas.openxmlformats.org/drawingml/2006/main">
+            <a:off x="8118000" y="4932000"/>
+            <a:ext cx="3391200" cy="252000"/>
+          </a:xfrm>
+          <a:prstGeom xmlns:a="http://schemas.openxmlformats.org/drawingml/2006/main" prst="rect">
+            <a:avLst/>
+          </a:prstGeom>
+          <a:noFill xmlns:a="http://schemas.openxmlformats.org/drawingml/2006/main"/>
+          <a:ln xmlns:a="http://schemas.openxmlformats.org/drawingml/2006/main">
+            <a:noFill/>
+          </a:ln>
+        </p:spPr>
+        <p:txBody>
+          <a:bodyPr xmlns:a="http://schemas.openxmlformats.org/drawingml/2006/main" lIns="0" tIns="0" rIns="0" bIns="0" anchor="ctr"/>
+          <a:lstStyle xmlns:a="http://schemas.openxmlformats.org/drawingml/2006/main"/>
+          <a:p xmlns:a="http://schemas.openxmlformats.org/drawingml/2006/main">
+            <a:pPr algn="l"/>
+            <a:r>
+              <a:rPr lang="en-US" sz="1050" b="1" spc="220">
+                <a:solidFill>
+                  <a:srgbClr val="C9A84C"/>
+                </a:solidFill>
+                <a:latin typeface="Arial"/>
+                <a:ea typeface="Arial"/>
+              </a:rPr>
               <a:t>EMAIL</a:t>
             </a:r>
           </a:p>
@@ -8912,8 +8929,8 @@
         </p:nvSpPr>
         <p:spPr>
           <a:xfrm xmlns:a="http://schemas.openxmlformats.org/drawingml/2006/main">
-            <a:off x="8118000" y="5364000"/>
-            <a:ext cx="3391200" cy="576000"/>
+            <a:off x="8118000" y="5220000"/>
+            <a:ext cx="3391200" cy="810000"/>
           </a:xfrm>
           <a:prstGeom xmlns:a="http://schemas.openxmlformats.org/drawingml/2006/main" prst="rect">
             <a:avLst/>

</xml_diff>